<commit_message>
Finalize presentation evidence and portable Worker build
</commit_message>
<xml_diff>
--- a/docs/RiskRadar-Presentation.pptx
+++ b/docs/RiskRadar-Presentation.pptx
@@ -2,19 +2,19 @@
 <file path=ppt/presentation.xml><?xml version="1.0" encoding="utf-8"?>
 <p:presentation xmlns:p="http://schemas.openxmlformats.org/presentationml/2006/main">
   <p:sldMasterIdLst>
-    <p:sldMasterId xmlns:r="http://schemas.openxmlformats.org/officeDocument/2006/relationships" id="2147483648" r:id="R23fe7fa13ec64e28"/>
+    <p:sldMasterId xmlns:r="http://schemas.openxmlformats.org/officeDocument/2006/relationships" id="2147483648" r:id="R1577e2e1990a4f7f"/>
   </p:sldMasterIdLst>
   <p:notesMasterIdLst>
-    <p:notesMasterId xmlns:r="http://schemas.openxmlformats.org/officeDocument/2006/relationships" r:id="R9b2e0decbac04019"/>
+    <p:notesMasterId xmlns:r="http://schemas.openxmlformats.org/officeDocument/2006/relationships" r:id="R4f1c15193fc34245"/>
   </p:notesMasterIdLst>
   <p:sldIdLst>
-    <p:sldId xmlns:r="http://schemas.openxmlformats.org/officeDocument/2006/relationships" id="256" r:id="R179ec4c45c174d26"/>
-    <p:sldId xmlns:r="http://schemas.openxmlformats.org/officeDocument/2006/relationships" id="257" r:id="R53db4c96e079421d"/>
-    <p:sldId xmlns:r="http://schemas.openxmlformats.org/officeDocument/2006/relationships" id="258" r:id="R33da12a4414341fd"/>
-    <p:sldId xmlns:r="http://schemas.openxmlformats.org/officeDocument/2006/relationships" id="259" r:id="Rd6bd9bd64f304871"/>
-    <p:sldId xmlns:r="http://schemas.openxmlformats.org/officeDocument/2006/relationships" id="260" r:id="R10567233b5394cce"/>
-    <p:sldId xmlns:r="http://schemas.openxmlformats.org/officeDocument/2006/relationships" id="261" r:id="Re32b921060ca4efb"/>
-    <p:sldId xmlns:r="http://schemas.openxmlformats.org/officeDocument/2006/relationships" id="262" r:id="R53469fec816a4c93"/>
+    <p:sldId xmlns:r="http://schemas.openxmlformats.org/officeDocument/2006/relationships" id="256" r:id="Rce3d7edc974b4c74"/>
+    <p:sldId xmlns:r="http://schemas.openxmlformats.org/officeDocument/2006/relationships" id="257" r:id="R7766b43b741843a8"/>
+    <p:sldId xmlns:r="http://schemas.openxmlformats.org/officeDocument/2006/relationships" id="258" r:id="R50f027f1f32246f0"/>
+    <p:sldId xmlns:r="http://schemas.openxmlformats.org/officeDocument/2006/relationships" id="259" r:id="Rfb2a70e5ca804c7a"/>
+    <p:sldId xmlns:r="http://schemas.openxmlformats.org/officeDocument/2006/relationships" id="260" r:id="R7ef4181d6a5e4b54"/>
+    <p:sldId xmlns:r="http://schemas.openxmlformats.org/officeDocument/2006/relationships" id="261" r:id="Rbc3c5b90540c42cf"/>
+    <p:sldId xmlns:r="http://schemas.openxmlformats.org/officeDocument/2006/relationships" id="262" r:id="Rc1b933a49a5a4de1"/>
   </p:sldIdLst>
   <p:sldSz cx="12192000" cy="6858000"/>
   <p:notesSz cx="6858000" cy="9144000"/>
@@ -915,7 +915,7 @@
           <p:cNvPr id="3" name="Title">
             <a:extLst xmlns:a="http://schemas.openxmlformats.org/drawingml/2006/main">
               <a:ext uri="{FF2B5EF4-FFF2-40B4-BE49-F238E27FC236}">
-                <a16:creationId xmlns:a16="http://schemas.microsoft.com/office/drawing/2014/main" id="{D6E4049B-260A-4955-B1A4-F8E5D66E0B83}"/>
+                <a16:creationId xmlns:a16="http://schemas.microsoft.com/office/drawing/2014/main" id="{71D915B1-25A9-446D-A31A-40F0E4C8B4CA}"/>
               </a:ext>
             </a:extLst>
           </p:cNvPr>
@@ -1072,7 +1072,7 @@
           <p:cNvPr id="2" name="Subtitle">
             <a:extLst xmlns:a="http://schemas.openxmlformats.org/drawingml/2006/main">
               <a:ext uri="{FF2B5EF4-FFF2-40B4-BE49-F238E27FC236}">
-                <a16:creationId xmlns:a16="http://schemas.microsoft.com/office/drawing/2014/main" id="{DA2FDE15-78A0-4466-921E-56AAB4829ADE}"/>
+                <a16:creationId xmlns:a16="http://schemas.microsoft.com/office/drawing/2014/main" id="{0CBC50DA-A00F-4B58-B995-11826FD2B843}"/>
               </a:ext>
             </a:extLst>
           </p:cNvPr>
@@ -1246,7 +1246,7 @@
           <p:cNvPr id="2" name="Section title">
             <a:extLst xmlns:a="http://schemas.openxmlformats.org/drawingml/2006/main">
               <a:ext uri="{FF2B5EF4-FFF2-40B4-BE49-F238E27FC236}">
-                <a16:creationId xmlns:a16="http://schemas.microsoft.com/office/drawing/2014/main" id="{89BE89A0-8F90-4DFC-897E-C0B87FAA66DF}"/>
+                <a16:creationId xmlns:a16="http://schemas.microsoft.com/office/drawing/2014/main" id="{30F7499E-18D3-4330-9BBF-A9472941BAAD}"/>
               </a:ext>
             </a:extLst>
           </p:cNvPr>
@@ -1420,7 +1420,7 @@
           <p:cNvPr id="3" name="Title">
             <a:extLst xmlns:a="http://schemas.openxmlformats.org/drawingml/2006/main">
               <a:ext uri="{FF2B5EF4-FFF2-40B4-BE49-F238E27FC236}">
-                <a16:creationId xmlns:a16="http://schemas.microsoft.com/office/drawing/2014/main" id="{5CC4A174-10A7-44FC-90C8-7B04A0FCBB37}"/>
+                <a16:creationId xmlns:a16="http://schemas.microsoft.com/office/drawing/2014/main" id="{92E4BBEF-ED45-4FE8-AC15-B577873052D5}"/>
               </a:ext>
             </a:extLst>
           </p:cNvPr>
@@ -1577,7 +1577,7 @@
           <p:cNvPr id="2" name="Body">
             <a:extLst xmlns:a="http://schemas.openxmlformats.org/drawingml/2006/main">
               <a:ext uri="{FF2B5EF4-FFF2-40B4-BE49-F238E27FC236}">
-                <a16:creationId xmlns:a16="http://schemas.microsoft.com/office/drawing/2014/main" id="{1289D43F-4046-4F3B-BBB3-89C79DBDD775}"/>
+                <a16:creationId xmlns:a16="http://schemas.microsoft.com/office/drawing/2014/main" id="{0F09EF42-58EC-417A-BB2A-7A558720298E}"/>
               </a:ext>
             </a:extLst>
           </p:cNvPr>
@@ -1751,7 +1751,7 @@
           <p:cNvPr id="4" name="Title">
             <a:extLst xmlns:a="http://schemas.openxmlformats.org/drawingml/2006/main">
               <a:ext uri="{FF2B5EF4-FFF2-40B4-BE49-F238E27FC236}">
-                <a16:creationId xmlns:a16="http://schemas.microsoft.com/office/drawing/2014/main" id="{0821DB90-6C18-4788-B6B6-DE338372EF61}"/>
+                <a16:creationId xmlns:a16="http://schemas.microsoft.com/office/drawing/2014/main" id="{DCC01645-2096-436D-9974-6CE4904E5B53}"/>
               </a:ext>
             </a:extLst>
           </p:cNvPr>
@@ -1908,7 +1908,7 @@
           <p:cNvPr id="2" name="Left column">
             <a:extLst xmlns:a="http://schemas.openxmlformats.org/drawingml/2006/main">
               <a:ext uri="{FF2B5EF4-FFF2-40B4-BE49-F238E27FC236}">
-                <a16:creationId xmlns:a16="http://schemas.microsoft.com/office/drawing/2014/main" id="{04680AF1-36F4-4B59-9E8F-97C2E23CCC34}"/>
+                <a16:creationId xmlns:a16="http://schemas.microsoft.com/office/drawing/2014/main" id="{11C1E0CC-D387-476C-936B-FC3A6EB8F8A5}"/>
               </a:ext>
             </a:extLst>
           </p:cNvPr>
@@ -2065,7 +2065,7 @@
           <p:cNvPr id="3" name="Right column">
             <a:extLst xmlns:a="http://schemas.openxmlformats.org/drawingml/2006/main">
               <a:ext uri="{FF2B5EF4-FFF2-40B4-BE49-F238E27FC236}">
-                <a16:creationId xmlns:a16="http://schemas.microsoft.com/office/drawing/2014/main" id="{8A8D1665-F2CA-4D16-AC05-F457733DDADF}"/>
+                <a16:creationId xmlns:a16="http://schemas.microsoft.com/office/drawing/2014/main" id="{E73A2D21-FF69-4DF8-BE6F-0C905D59397A}"/>
               </a:ext>
             </a:extLst>
           </p:cNvPr>
@@ -2239,7 +2239,7 @@
           <p:cNvPr id="3" name="Title">
             <a:extLst xmlns:a="http://schemas.openxmlformats.org/drawingml/2006/main">
               <a:ext uri="{FF2B5EF4-FFF2-40B4-BE49-F238E27FC236}">
-                <a16:creationId xmlns:a16="http://schemas.microsoft.com/office/drawing/2014/main" id="{F96D579B-D9F4-46DA-8760-98042D0E48D4}"/>
+                <a16:creationId xmlns:a16="http://schemas.microsoft.com/office/drawing/2014/main" id="{17BA23A5-E0C7-418A-9953-35BF1C4B49C1}"/>
               </a:ext>
             </a:extLst>
           </p:cNvPr>
@@ -2396,7 +2396,7 @@
           <p:cNvPr id="2" name="Left column">
             <a:extLst xmlns:a="http://schemas.openxmlformats.org/drawingml/2006/main">
               <a:ext uri="{FF2B5EF4-FFF2-40B4-BE49-F238E27FC236}">
-                <a16:creationId xmlns:a16="http://schemas.microsoft.com/office/drawing/2014/main" id="{23182BE7-A876-4C4B-B527-143F6D50A229}"/>
+                <a16:creationId xmlns:a16="http://schemas.microsoft.com/office/drawing/2014/main" id="{F0D8D164-F93E-4605-B0EC-65C6BADDEBBC}"/>
               </a:ext>
             </a:extLst>
           </p:cNvPr>
@@ -2591,12 +2591,12 @@
   </p:cSld>
   <p:clrMap bg1="lt1" tx1="dk1" bg2="lt2" tx2="dk2" accent1="accent1" accent2="accent2" accent3="accent3" accent4="accent4" accent5="accent5" accent6="accent6" hlink="hlink" folHlink="folHlink"/>
   <p:sldLayoutIdLst>
-    <p:sldLayoutId xmlns:r="http://schemas.openxmlformats.org/officeDocument/2006/relationships" id="2147483649" r:id="R20535d6d5d8140b3"/>
-    <p:sldLayoutId xmlns:r="http://schemas.openxmlformats.org/officeDocument/2006/relationships" id="2147483650" r:id="Ra347b4d99499434d"/>
-    <p:sldLayoutId xmlns:r="http://schemas.openxmlformats.org/officeDocument/2006/relationships" id="2147483651" r:id="Rf8eed06308d546e3"/>
-    <p:sldLayoutId xmlns:r="http://schemas.openxmlformats.org/officeDocument/2006/relationships" id="2147483652" r:id="R368ed945d15642fe"/>
-    <p:sldLayoutId xmlns:r="http://schemas.openxmlformats.org/officeDocument/2006/relationships" id="2147483653" r:id="Rbcc72b9b88144296"/>
-    <p:sldLayoutId xmlns:r="http://schemas.openxmlformats.org/officeDocument/2006/relationships" id="2147483654" r:id="Rbfb8fa43836d418b"/>
+    <p:sldLayoutId xmlns:r="http://schemas.openxmlformats.org/officeDocument/2006/relationships" id="2147483649" r:id="Rdc8aab095aa04eb1"/>
+    <p:sldLayoutId xmlns:r="http://schemas.openxmlformats.org/officeDocument/2006/relationships" id="2147483650" r:id="R67e61f20fb2141eb"/>
+    <p:sldLayoutId xmlns:r="http://schemas.openxmlformats.org/officeDocument/2006/relationships" id="2147483651" r:id="Rc51a3df087534061"/>
+    <p:sldLayoutId xmlns:r="http://schemas.openxmlformats.org/officeDocument/2006/relationships" id="2147483652" r:id="R8ed1894533944004"/>
+    <p:sldLayoutId xmlns:r="http://schemas.openxmlformats.org/officeDocument/2006/relationships" id="2147483653" r:id="R4d55112605fd41eb"/>
+    <p:sldLayoutId xmlns:r="http://schemas.openxmlformats.org/officeDocument/2006/relationships" id="2147483654" r:id="R709be89fef214d97"/>
   </p:sldLayoutIdLst>
   <p:txStyles>
     <p:titleStyle>
@@ -3555,7 +3555,7 @@
           <p:cNvPr id="4" name="">
             <a:extLst xmlns:a="http://schemas.openxmlformats.org/drawingml/2006/main">
               <a:ext uri="{FF2B5EF4-FFF2-40B4-BE49-F238E27FC236}">
-                <a16:creationId xmlns:a16="http://schemas.microsoft.com/office/drawing/2014/main" id="{78F30639-ECE7-4BDA-80E7-0A485FA2D0EB}"/>
+                <a16:creationId xmlns:a16="http://schemas.microsoft.com/office/drawing/2014/main" id="{869F85A6-B749-4056-BF14-BD6ECF9123FD}"/>
               </a:ext>
             </a:extLst>
           </p:cNvPr>
@@ -3621,7 +3621,7 @@
           <p:cNvPr id="2" name="">
             <a:extLst xmlns:a="http://schemas.openxmlformats.org/drawingml/2006/main">
               <a:ext uri="{FF2B5EF4-FFF2-40B4-BE49-F238E27FC236}">
-                <a16:creationId xmlns:a16="http://schemas.microsoft.com/office/drawing/2014/main" id="{B69054BD-A8B6-47D8-BF4D-B692B4100364}"/>
+                <a16:creationId xmlns:a16="http://schemas.microsoft.com/office/drawing/2014/main" id="{680A1DAB-F42D-44DC-8B89-47EE02C05EA8}"/>
               </a:ext>
             </a:extLst>
           </p:cNvPr>
@@ -3789,7 +3789,7 @@
           <p:cNvPr id="3" name="">
             <a:extLst xmlns:a="http://schemas.openxmlformats.org/drawingml/2006/main">
               <a:ext uri="{FF2B5EF4-FFF2-40B4-BE49-F238E27FC236}">
-                <a16:creationId xmlns:a16="http://schemas.microsoft.com/office/drawing/2014/main" id="{68436ABA-A893-4CDD-8971-E7E6D7AC3BD4}"/>
+                <a16:creationId xmlns:a16="http://schemas.microsoft.com/office/drawing/2014/main" id="{3EB8AD8B-6EF0-4C66-9C8E-1970603DBD90}"/>
               </a:ext>
             </a:extLst>
           </p:cNvPr>
@@ -3853,7 +3853,7 @@
     </p:spTree>
     <p:extLst>
       <p:ext uri="{BB962C8B-B14F-4D97-AF65-F5344CB8AC3E}">
-        <p14:creationId xmlns:p14="http://schemas.microsoft.com/office/powerpoint/2010/main" val="2082002374"/>
+        <p14:creationId xmlns:p14="http://schemas.microsoft.com/office/powerpoint/2010/main" val="569203798"/>
       </p:ext>
     </p:extLst>
   </p:cSld>
@@ -3884,7 +3884,7 @@
           <p:cNvPr id="4" name="">
             <a:extLst xmlns:a="http://schemas.openxmlformats.org/drawingml/2006/main">
               <a:ext uri="{FF2B5EF4-FFF2-40B4-BE49-F238E27FC236}">
-                <a16:creationId xmlns:a16="http://schemas.microsoft.com/office/drawing/2014/main" id="{362D743F-7DDF-4AB9-8B90-1544A1999521}"/>
+                <a16:creationId xmlns:a16="http://schemas.microsoft.com/office/drawing/2014/main" id="{B2AC617F-FE9E-48E3-8453-33F6CB8F467C}"/>
               </a:ext>
             </a:extLst>
           </p:cNvPr>
@@ -3950,7 +3950,7 @@
           <p:cNvPr id="2" name="">
             <a:extLst xmlns:a="http://schemas.openxmlformats.org/drawingml/2006/main">
               <a:ext uri="{FF2B5EF4-FFF2-40B4-BE49-F238E27FC236}">
-                <a16:creationId xmlns:a16="http://schemas.microsoft.com/office/drawing/2014/main" id="{B7DB4AF1-3EEB-4D2A-A2D6-8502E82E7B25}"/>
+                <a16:creationId xmlns:a16="http://schemas.microsoft.com/office/drawing/2014/main" id="{626138BC-D3B2-4784-BDD7-C377B3DC69DA}"/>
               </a:ext>
             </a:extLst>
           </p:cNvPr>
@@ -4141,7 +4141,7 @@
           <p:cNvPr id="3" name="">
             <a:extLst xmlns:a="http://schemas.openxmlformats.org/drawingml/2006/main">
               <a:ext uri="{FF2B5EF4-FFF2-40B4-BE49-F238E27FC236}">
-                <a16:creationId xmlns:a16="http://schemas.microsoft.com/office/drawing/2014/main" id="{417828E6-035E-4AD6-97EB-30D0A5A86EC3}"/>
+                <a16:creationId xmlns:a16="http://schemas.microsoft.com/office/drawing/2014/main" id="{07E4EE76-510A-4656-BE5A-72143BDB1B7C}"/>
               </a:ext>
             </a:extLst>
           </p:cNvPr>
@@ -4205,7 +4205,7 @@
     </p:spTree>
     <p:extLst>
       <p:ext uri="{BB962C8B-B14F-4D97-AF65-F5344CB8AC3E}">
-        <p14:creationId xmlns:p14="http://schemas.microsoft.com/office/powerpoint/2010/main" val="126949534"/>
+        <p14:creationId xmlns:p14="http://schemas.microsoft.com/office/powerpoint/2010/main" val="529103258"/>
       </p:ext>
     </p:extLst>
   </p:cSld>
@@ -4236,7 +4236,7 @@
           <p:cNvPr id="4" name="">
             <a:extLst xmlns:a="http://schemas.openxmlformats.org/drawingml/2006/main">
               <a:ext uri="{FF2B5EF4-FFF2-40B4-BE49-F238E27FC236}">
-                <a16:creationId xmlns:a16="http://schemas.microsoft.com/office/drawing/2014/main" id="{546FE0EA-CD5B-45E0-A7B4-8858170036C4}"/>
+                <a16:creationId xmlns:a16="http://schemas.microsoft.com/office/drawing/2014/main" id="{473052DF-BE1D-4425-8804-EB4223CBC6AA}"/>
               </a:ext>
             </a:extLst>
           </p:cNvPr>
@@ -4302,7 +4302,7 @@
           <p:cNvPr id="2" name="">
             <a:extLst xmlns:a="http://schemas.openxmlformats.org/drawingml/2006/main">
               <a:ext uri="{FF2B5EF4-FFF2-40B4-BE49-F238E27FC236}">
-                <a16:creationId xmlns:a16="http://schemas.microsoft.com/office/drawing/2014/main" id="{EC5D1C58-849A-431F-B165-284819AC5518}"/>
+                <a16:creationId xmlns:a16="http://schemas.microsoft.com/office/drawing/2014/main" id="{79FA0949-664E-4FE9-99A2-4BE7E1C0FADD}"/>
               </a:ext>
             </a:extLst>
           </p:cNvPr>
@@ -4493,7 +4493,7 @@
           <p:cNvPr id="3" name="">
             <a:extLst xmlns:a="http://schemas.openxmlformats.org/drawingml/2006/main">
               <a:ext uri="{FF2B5EF4-FFF2-40B4-BE49-F238E27FC236}">
-                <a16:creationId xmlns:a16="http://schemas.microsoft.com/office/drawing/2014/main" id="{7C8A7A5F-2850-4C37-99C1-0ED6310D5D29}"/>
+                <a16:creationId xmlns:a16="http://schemas.microsoft.com/office/drawing/2014/main" id="{390568B7-D72D-4686-AA27-3EADAECAFF58}"/>
               </a:ext>
             </a:extLst>
           </p:cNvPr>
@@ -4557,7 +4557,7 @@
     </p:spTree>
     <p:extLst>
       <p:ext uri="{BB962C8B-B14F-4D97-AF65-F5344CB8AC3E}">
-        <p14:creationId xmlns:p14="http://schemas.microsoft.com/office/powerpoint/2010/main" val="1726539321"/>
+        <p14:creationId xmlns:p14="http://schemas.microsoft.com/office/powerpoint/2010/main" val="1822283173"/>
       </p:ext>
     </p:extLst>
   </p:cSld>
@@ -4588,7 +4588,7 @@
           <p:cNvPr id="4" name="">
             <a:extLst xmlns:a="http://schemas.openxmlformats.org/drawingml/2006/main">
               <a:ext uri="{FF2B5EF4-FFF2-40B4-BE49-F238E27FC236}">
-                <a16:creationId xmlns:a16="http://schemas.microsoft.com/office/drawing/2014/main" id="{8E6E59F3-CFAC-443B-855A-E085E6235C10}"/>
+                <a16:creationId xmlns:a16="http://schemas.microsoft.com/office/drawing/2014/main" id="{ADDAFAE5-A6D7-4B76-B9E5-0177C2FD3C6B}"/>
               </a:ext>
             </a:extLst>
           </p:cNvPr>
@@ -4654,7 +4654,7 @@
           <p:cNvPr id="2" name="">
             <a:extLst xmlns:a="http://schemas.openxmlformats.org/drawingml/2006/main">
               <a:ext uri="{FF2B5EF4-FFF2-40B4-BE49-F238E27FC236}">
-                <a16:creationId xmlns:a16="http://schemas.microsoft.com/office/drawing/2014/main" id="{20BBDF67-9773-46F6-9C90-56B1382E8E90}"/>
+                <a16:creationId xmlns:a16="http://schemas.microsoft.com/office/drawing/2014/main" id="{6B9FAFB8-41C8-4933-8D7C-BA4362E12A32}"/>
               </a:ext>
             </a:extLst>
           </p:cNvPr>
@@ -4807,7 +4807,7 @@
                 <a:ea typeface="Arial"/>
                 <a:cs typeface="Arial"/>
               </a:rPr>
-              <a:t>Sentiment −0.519  |  Geopolitical  |  Impact 10</a:t>
+              <a:t>Sentiment −0.519  |  Geopolitical  |  Impact 9</a:t>
             </a:r>
           </a:p>
           <a:p xmlns:a="http://schemas.openxmlformats.org/drawingml/2006/main">
@@ -4845,7 +4845,7 @@
           <p:cNvPr id="3" name="">
             <a:extLst xmlns:a="http://schemas.openxmlformats.org/drawingml/2006/main">
               <a:ext uri="{FF2B5EF4-FFF2-40B4-BE49-F238E27FC236}">
-                <a16:creationId xmlns:a16="http://schemas.microsoft.com/office/drawing/2014/main" id="{2D5F89F2-A2C9-4023-9163-46A6483CA11B}"/>
+                <a16:creationId xmlns:a16="http://schemas.microsoft.com/office/drawing/2014/main" id="{655BDE2C-AB63-4E4E-BBAC-DDEFCE87F96C}"/>
               </a:ext>
             </a:extLst>
           </p:cNvPr>
@@ -4909,7 +4909,7 @@
     </p:spTree>
     <p:extLst>
       <p:ext uri="{BB962C8B-B14F-4D97-AF65-F5344CB8AC3E}">
-        <p14:creationId xmlns:p14="http://schemas.microsoft.com/office/powerpoint/2010/main" val="1256467798"/>
+        <p14:creationId xmlns:p14="http://schemas.microsoft.com/office/powerpoint/2010/main" val="912121994"/>
       </p:ext>
     </p:extLst>
   </p:cSld>
@@ -4940,7 +4940,7 @@
           <p:cNvPr id="6" name="">
             <a:extLst xmlns:a="http://schemas.openxmlformats.org/drawingml/2006/main">
               <a:ext uri="{FF2B5EF4-FFF2-40B4-BE49-F238E27FC236}">
-                <a16:creationId xmlns:a16="http://schemas.microsoft.com/office/drawing/2014/main" id="{9D2EC5E7-9A05-4A10-9229-A9CB2DD4EC39}"/>
+                <a16:creationId xmlns:a16="http://schemas.microsoft.com/office/drawing/2014/main" id="{8DD03D95-DAA6-45F1-BED3-D72364095F7C}"/>
               </a:ext>
             </a:extLst>
           </p:cNvPr>
@@ -5006,7 +5006,7 @@
           <p:cNvPr id="2" name="">
             <a:extLst xmlns:a="http://schemas.openxmlformats.org/drawingml/2006/main">
               <a:ext uri="{FF2B5EF4-FFF2-40B4-BE49-F238E27FC236}">
-                <a16:creationId xmlns:a16="http://schemas.microsoft.com/office/drawing/2014/main" id="{FF29F5DF-4481-4F8D-B2C9-F09B0A4F7484}"/>
+                <a16:creationId xmlns:a16="http://schemas.microsoft.com/office/drawing/2014/main" id="{0514D1D6-06A0-4A4D-8FC7-3F64D5CED784}"/>
               </a:ext>
             </a:extLst>
           </p:cNvPr>
@@ -5169,7 +5169,7 @@
           <p:cNvPr id="3" name="">
             <a:extLst xmlns:a="http://schemas.openxmlformats.org/drawingml/2006/main">
               <a:ext uri="{FF2B5EF4-FFF2-40B4-BE49-F238E27FC236}">
-                <a16:creationId xmlns:a16="http://schemas.microsoft.com/office/drawing/2014/main" id="{E1D20B0F-8582-412A-A489-66EEDB0CD714}"/>
+                <a16:creationId xmlns:a16="http://schemas.microsoft.com/office/drawing/2014/main" id="{662013CC-6EAE-4A4C-A4BD-3A9066C11166}"/>
               </a:ext>
             </a:extLst>
           </p:cNvPr>
@@ -5235,7 +5235,7 @@
           <p:cNvPr id="4" name="Chart">
             <a:extLst xmlns:a="http://schemas.openxmlformats.org/drawingml/2006/main">
               <a:ext uri="{FF2B5EF4-FFF2-40B4-BE49-F238E27FC236}">
-                <a16:creationId xmlns:a16="http://schemas.microsoft.com/office/drawing/2014/main" id="{17A5CF06-0B51-4AB7-BF62-56629DAF3877}"/>
+                <a16:creationId xmlns:a16="http://schemas.microsoft.com/office/drawing/2014/main" id="{9D10C3DE-6ADB-46F3-BD9E-FDDB491F4014}"/>
               </a:ext>
             </a:extLst>
           </p:cNvPr>
@@ -5248,7 +5248,7 @@
         </p:xfrm>
         <a:graphic xmlns:a="http://schemas.openxmlformats.org/drawingml/2006/main">
           <a:graphicData uri="http://schemas.openxmlformats.org/drawingml/2006/chart">
-            <c:chart xmlns:r="http://schemas.openxmlformats.org/officeDocument/2006/relationships" xmlns:c="http://schemas.openxmlformats.org/drawingml/2006/chart" r:id="R6d1572634c264e07"/>
+            <c:chart xmlns:r="http://schemas.openxmlformats.org/officeDocument/2006/relationships" xmlns:c="http://schemas.openxmlformats.org/drawingml/2006/chart" r:id="R935b01ad284a43c4"/>
           </a:graphicData>
         </a:graphic>
       </p:graphicFrame>
@@ -5257,7 +5257,7 @@
           <p:cNvPr id="5" name="">
             <a:extLst xmlns:a="http://schemas.openxmlformats.org/drawingml/2006/main">
               <a:ext uri="{FF2B5EF4-FFF2-40B4-BE49-F238E27FC236}">
-                <a16:creationId xmlns:a16="http://schemas.microsoft.com/office/drawing/2014/main" id="{350EA82B-7641-4A34-A890-BFC98C8BB46E}"/>
+                <a16:creationId xmlns:a16="http://schemas.microsoft.com/office/drawing/2014/main" id="{82B7733C-DCA3-4216-BFA3-759AD15E8BF4}"/>
               </a:ext>
             </a:extLst>
           </p:cNvPr>
@@ -5321,7 +5321,7 @@
     </p:spTree>
     <p:extLst>
       <p:ext uri="{BB962C8B-B14F-4D97-AF65-F5344CB8AC3E}">
-        <p14:creationId xmlns:p14="http://schemas.microsoft.com/office/powerpoint/2010/main" val="403215207"/>
+        <p14:creationId xmlns:p14="http://schemas.microsoft.com/office/powerpoint/2010/main" val="272518805"/>
       </p:ext>
     </p:extLst>
   </p:cSld>
@@ -5352,7 +5352,7 @@
           <p:cNvPr id="5" name="">
             <a:extLst xmlns:a="http://schemas.openxmlformats.org/drawingml/2006/main">
               <a:ext uri="{FF2B5EF4-FFF2-40B4-BE49-F238E27FC236}">
-                <a16:creationId xmlns:a16="http://schemas.microsoft.com/office/drawing/2014/main" id="{3E862588-447E-4C7F-9073-9D352072C582}"/>
+                <a16:creationId xmlns:a16="http://schemas.microsoft.com/office/drawing/2014/main" id="{5608638B-C0E2-4876-94DD-9CFF7903150C}"/>
               </a:ext>
             </a:extLst>
           </p:cNvPr>
@@ -5418,7 +5418,7 @@
           <p:cNvPr id="2" name="">
             <a:extLst xmlns:a="http://schemas.openxmlformats.org/drawingml/2006/main">
               <a:ext uri="{FF2B5EF4-FFF2-40B4-BE49-F238E27FC236}">
-                <a16:creationId xmlns:a16="http://schemas.microsoft.com/office/drawing/2014/main" id="{58ADDB2A-38E5-4100-9F6D-1193B2BA305F}"/>
+                <a16:creationId xmlns:a16="http://schemas.microsoft.com/office/drawing/2014/main" id="{E5D69397-ADB5-4B68-B9AA-1AB40CE617E7}"/>
               </a:ext>
             </a:extLst>
           </p:cNvPr>
@@ -5530,7 +5530,7 @@
           <p:cNvPr id="3" name="">
             <a:extLst xmlns:a="http://schemas.openxmlformats.org/drawingml/2006/main">
               <a:ext uri="{FF2B5EF4-FFF2-40B4-BE49-F238E27FC236}">
-                <a16:creationId xmlns:a16="http://schemas.microsoft.com/office/drawing/2014/main" id="{57448448-D94B-454E-A3B3-E85932CEE68D}"/>
+                <a16:creationId xmlns:a16="http://schemas.microsoft.com/office/drawing/2014/main" id="{5E6C2D11-6250-47E2-8938-BB639DBF7380}"/>
               </a:ext>
             </a:extLst>
           </p:cNvPr>
@@ -5596,7 +5596,7 @@
           <p:cNvPr id="4" name="Chart">
             <a:extLst xmlns:a="http://schemas.openxmlformats.org/drawingml/2006/main">
               <a:ext uri="{FF2B5EF4-FFF2-40B4-BE49-F238E27FC236}">
-                <a16:creationId xmlns:a16="http://schemas.microsoft.com/office/drawing/2014/main" id="{AC14FE5F-74A5-4F1F-964C-8DF9E8383B10}"/>
+                <a16:creationId xmlns:a16="http://schemas.microsoft.com/office/drawing/2014/main" id="{E3AA29C5-A840-4129-9EEB-06B4AD4C0F6C}"/>
               </a:ext>
             </a:extLst>
           </p:cNvPr>
@@ -5609,14 +5609,14 @@
         </p:xfrm>
         <a:graphic xmlns:a="http://schemas.openxmlformats.org/drawingml/2006/main">
           <a:graphicData uri="http://schemas.openxmlformats.org/drawingml/2006/chart">
-            <c:chart xmlns:r="http://schemas.openxmlformats.org/officeDocument/2006/relationships" xmlns:c="http://schemas.openxmlformats.org/drawingml/2006/chart" r:id="R9d78aa0c6734400d"/>
+            <c:chart xmlns:r="http://schemas.openxmlformats.org/officeDocument/2006/relationships" xmlns:c="http://schemas.openxmlformats.org/drawingml/2006/chart" r:id="R17229f779e3741b5"/>
           </a:graphicData>
         </a:graphic>
       </p:graphicFrame>
     </p:spTree>
     <p:extLst>
       <p:ext uri="{BB962C8B-B14F-4D97-AF65-F5344CB8AC3E}">
-        <p14:creationId xmlns:p14="http://schemas.microsoft.com/office/powerpoint/2010/main" val="252148667"/>
+        <p14:creationId xmlns:p14="http://schemas.microsoft.com/office/powerpoint/2010/main" val="1955831204"/>
       </p:ext>
     </p:extLst>
   </p:cSld>
@@ -5647,7 +5647,7 @@
           <p:cNvPr id="4" name="">
             <a:extLst xmlns:a="http://schemas.openxmlformats.org/drawingml/2006/main">
               <a:ext uri="{FF2B5EF4-FFF2-40B4-BE49-F238E27FC236}">
-                <a16:creationId xmlns:a16="http://schemas.microsoft.com/office/drawing/2014/main" id="{9E324DFF-D609-49DB-B031-CC418BD9B96E}"/>
+                <a16:creationId xmlns:a16="http://schemas.microsoft.com/office/drawing/2014/main" id="{95A1640A-1A07-47DB-A08A-14E474C5AC2D}"/>
               </a:ext>
             </a:extLst>
           </p:cNvPr>
@@ -5713,7 +5713,7 @@
           <p:cNvPr id="2" name="">
             <a:extLst xmlns:a="http://schemas.openxmlformats.org/drawingml/2006/main">
               <a:ext uri="{FF2B5EF4-FFF2-40B4-BE49-F238E27FC236}">
-                <a16:creationId xmlns:a16="http://schemas.microsoft.com/office/drawing/2014/main" id="{01764201-6AF3-4D72-A024-01ABAC676CDA}"/>
+                <a16:creationId xmlns:a16="http://schemas.microsoft.com/office/drawing/2014/main" id="{FF25A116-2E25-460A-B876-F57A68608359}"/>
               </a:ext>
             </a:extLst>
           </p:cNvPr>
@@ -5904,7 +5904,7 @@
           <p:cNvPr id="3" name="">
             <a:extLst xmlns:a="http://schemas.openxmlformats.org/drawingml/2006/main">
               <a:ext uri="{FF2B5EF4-FFF2-40B4-BE49-F238E27FC236}">
-                <a16:creationId xmlns:a16="http://schemas.microsoft.com/office/drawing/2014/main" id="{DCB893F8-C7F0-42CA-87E6-F024F48D3CEF}"/>
+                <a16:creationId xmlns:a16="http://schemas.microsoft.com/office/drawing/2014/main" id="{2C1F6309-510A-4CA5-808E-D45B05574B69}"/>
               </a:ext>
             </a:extLst>
           </p:cNvPr>
@@ -5968,7 +5968,7 @@
     </p:spTree>
     <p:extLst>
       <p:ext uri="{BB962C8B-B14F-4D97-AF65-F5344CB8AC3E}">
-        <p14:creationId xmlns:p14="http://schemas.microsoft.com/office/powerpoint/2010/main" val="140966718"/>
+        <p14:creationId xmlns:p14="http://schemas.microsoft.com/office/powerpoint/2010/main" val="1445829220"/>
       </p:ext>
     </p:extLst>
   </p:cSld>

</xml_diff>

<commit_message>
Complete hackathon packaging: datasets, architecture, license, required README and seven-slide deck
</commit_message>
<xml_diff>
--- a/docs/RiskRadar-Presentation.pptx
+++ b/docs/RiskRadar-Presentation.pptx
@@ -2,19 +2,19 @@
 <file path=ppt/presentation.xml><?xml version="1.0" encoding="utf-8"?>
 <p:presentation xmlns:p="http://schemas.openxmlformats.org/presentationml/2006/main">
   <p:sldMasterIdLst>
-    <p:sldMasterId xmlns:r="http://schemas.openxmlformats.org/officeDocument/2006/relationships" id="2147483648" r:id="R1577e2e1990a4f7f"/>
+    <p:sldMasterId xmlns:r="http://schemas.openxmlformats.org/officeDocument/2006/relationships" id="2147483648" r:id="R7aa0265d7a0a4167"/>
   </p:sldMasterIdLst>
   <p:notesMasterIdLst>
-    <p:notesMasterId xmlns:r="http://schemas.openxmlformats.org/officeDocument/2006/relationships" r:id="R4f1c15193fc34245"/>
+    <p:notesMasterId xmlns:r="http://schemas.openxmlformats.org/officeDocument/2006/relationships" r:id="Rf6d7fd5231404000"/>
   </p:notesMasterIdLst>
   <p:sldIdLst>
-    <p:sldId xmlns:r="http://schemas.openxmlformats.org/officeDocument/2006/relationships" id="256" r:id="Rce3d7edc974b4c74"/>
-    <p:sldId xmlns:r="http://schemas.openxmlformats.org/officeDocument/2006/relationships" id="257" r:id="R7766b43b741843a8"/>
-    <p:sldId xmlns:r="http://schemas.openxmlformats.org/officeDocument/2006/relationships" id="258" r:id="R50f027f1f32246f0"/>
-    <p:sldId xmlns:r="http://schemas.openxmlformats.org/officeDocument/2006/relationships" id="259" r:id="Rfb2a70e5ca804c7a"/>
-    <p:sldId xmlns:r="http://schemas.openxmlformats.org/officeDocument/2006/relationships" id="260" r:id="R7ef4181d6a5e4b54"/>
-    <p:sldId xmlns:r="http://schemas.openxmlformats.org/officeDocument/2006/relationships" id="261" r:id="Rbc3c5b90540c42cf"/>
-    <p:sldId xmlns:r="http://schemas.openxmlformats.org/officeDocument/2006/relationships" id="262" r:id="Rc1b933a49a5a4de1"/>
+    <p:sldId xmlns:r="http://schemas.openxmlformats.org/officeDocument/2006/relationships" id="256" r:id="R2c6e7b261a8e4e79"/>
+    <p:sldId xmlns:r="http://schemas.openxmlformats.org/officeDocument/2006/relationships" id="257" r:id="R6c2d7729468c423e"/>
+    <p:sldId xmlns:r="http://schemas.openxmlformats.org/officeDocument/2006/relationships" id="258" r:id="Raac83ae17f3b46e1"/>
+    <p:sldId xmlns:r="http://schemas.openxmlformats.org/officeDocument/2006/relationships" id="259" r:id="R29a2fac365784411"/>
+    <p:sldId xmlns:r="http://schemas.openxmlformats.org/officeDocument/2006/relationships" id="260" r:id="R93c45c9013a24cc5"/>
+    <p:sldId xmlns:r="http://schemas.openxmlformats.org/officeDocument/2006/relationships" id="261" r:id="R3bd19aa10f0a4383"/>
+    <p:sldId xmlns:r="http://schemas.openxmlformats.org/officeDocument/2006/relationships" id="262" r:id="Rfae5db58605d429c"/>
   </p:sldIdLst>
   <p:sldSz cx="12192000" cy="6858000"/>
   <p:notesSz cx="6858000" cy="9144000"/>
@@ -448,7 +448,7 @@
           <a:lstStyle xmlns:a="http://schemas.openxmlformats.org/drawingml/2006/main"/>
           <a:p xmlns:a="http://schemas.openxmlformats.org/drawingml/2006/main">
             <a:r>
-              <a:t>Working prototype built for the provided case study. Real financial text trains sentiment. Own synthetic holdings, shocks and replay inputs demonstrate downstream behavior. No trading performance or calibrated market-impact prediction is claimed.</a:t>
+              <a:t>Individual submission by Aarohi Chadha, IGDTUW. Working financial-text prototype. AI assistance supported implementation and documentation, as disclosed in README. Real public text trains sentiment. Synthetic fixtures demonstrate portfolio behavior.</a:t>
             </a:r>
           </a:p>
         </p:txBody>
@@ -518,7 +518,7 @@
           <a:lstStyle xmlns:a="http://schemas.openxmlformats.org/drawingml/2006/main"/>
           <a:p xmlns:a="http://schemas.openxmlformats.org/drawingml/2006/main">
             <a:r>
-              <a:t>Fixed allowlisted RSS connectors; bounded responses, 15-second timeout, 60-second cache. Browser inference and Python inference share exported logistic-regression parameters. Hosted API has no visitor persistence; local server uses SQLite. Both sources were fetched successfully during development. Source links are preserved.</a:t>
+              <a:t>Problem interpretation based on the supplied case study. Decision support is the intended use. No analyst time saving, trading performance or production risk accuracy is measured. Both modules use explicit, inspectable assumptions.</a:t>
             </a:r>
           </a:p>
         </p:txBody>
@@ -588,7 +588,7 @@
           <a:lstStyle xmlns:a="http://schemas.openxmlformats.org/drawingml/2006/main"/>
           <a:p xmlns:a="http://schemas.openxmlformats.org/drawingml/2006/main">
             <a:r>
-              <a:t>Dataset: https://huggingface.co/datasets/zeroshot/twitter-financial-news-sentiment revision ccbe24de388e287beb92dd393a335c376b350ac3. Downloaded original train 9543, validation 2388; 55 canonical overlaps removed from evaluation. C=4, max 16000 features, random_state=42. No evaluation-set hyperparameter tuning. Publisher card reports MIT; source texts are not redistributed. Evaluation is not temporal or entity-disjoint and measures only sentiment, not impact or investment outcomes. See docs/DATASET.md and data/evaluation.json.</a:t>
+              <a:t>Live BBC Business and Guardian Business RSS supply title/description records with source URL and timestamp. Manual/replay records also enter the engine. TF-IDF/logistic regression supplies sentiment; keyword rules supply event/impact. Python API stores local signals in SQLite. Public ESM Worker handles feeds; GitHub Pages runs browser inference. Public session state is in memory. JSON exports contain signals, stress and every position history.</a:t>
             </a:r>
           </a:p>
         </p:txBody>
@@ -658,7 +658,7 @@
           <a:lstStyle xmlns:a="http://schemas.openxmlformats.org/drawingml/2006/main"/>
           <a:p xmlns:a="http://schemas.openxmlformats.org/drawingml/2006/main">
             <a:r>
-              <a:t>The war replay text is synthetic, not a real news claim. Impact and event classification use transparent keyword rules; they are not trained or validated market-impact forecasts. Probabilities are not calibrated confidence. A low-confidence flag is shown below 0.55 maximum class probability. Company alias matching is intentionally simple. Outputs are available via API and JSON exports.</a:t>
+              <a:t>Dataset https://huggingface.co/datasets/zeroshot/twitter-financial-news-sentiment revision ccbe24de388e287beb92dd393a335c376b350ac3. Raw downloaded rows 9543 train, 2388 validation. Evaluation overlap removed 55. TF-IDF unigram/bigram max16000 min_df2 sublinear_tf, logistic regression C4 balanced seed42. No evaluation tuning. Not temporal/entity-disjoint. Accuracy 0.82053494391717, macro F1 0.7605247651302703, sentiment only. Raw CSVs, cleaned splits, card and hashes bundled in data/. Python unit tests9 pass; API integration, JS parity and both publishers verified. Probabilities uncalibrated. Severity estimate is not a market prediction.</a:t>
             </a:r>
           </a:p>
         </p:txBody>
@@ -728,7 +728,7 @@
           <a:lstStyle xmlns:a="http://schemas.openxmlformats.org/drawingml/2006/main"/>
           <a:p xmlns:a="http://schemas.openxmlformats.org/drawingml/2006/main">
             <a:r>
-              <a:t>Own synthetic portfolio: $4m loan, $3m bond, $2m equity and $1m derivative. Geopolitical shock: equity -10%, rates +2 percentage points, spread +1.5 percentage points. Loan duration/spread duration 2/2; bond 5/4; equity beta 1; derivative rate sensitivity -$3m per unit rate move. Simplified linear scenario; no historical calibration. Loan 280k, bond 480k, equity 200k, derivative 60k.</a:t>
+              <a:t>Synthetic portfolio $4m loan $3m bond $2m equity $1m derivative. Shocks equity -10%, rates +2pp, spreads +1.5pp. Loan durations2/2, bond5/4, equitybeta1, derivative signedratesensitivity -$3m/unit rate. Losses280k480k200k60k. War sentiment-.519. Illustrative linear exposures and shocks, no historical calibration.</a:t>
             </a:r>
           </a:p>
         </p:txBody>
@@ -798,7 +798,7 @@
           <a:lstStyle xmlns:a="http://schemas.openxmlformats.org/drawingml/2006/main"/>
           <a:p xmlns:a="http://schemas.openxmlformats.org/drawingml/2006/main">
             <a:r>
-              <a:t>Own illustrative ticker basket; current index membership is not asserted. Replay final weights shown. Positive sentiment increases raw weight, negative decreases it, then weights normalize across the basket. GLOBAL events do not change company weights. No trades, transaction costs, market price backtest or outperformance claim.</a:t>
+              <a:t>Synthetic mock index. Current index membership not asserted. GLOBAL signals do not alter company weights. Replay final weights shown. No trade execution, price backtest, costs or outperformance claim. Chart history traces three named positions while exports include allten.</a:t>
             </a:r>
           </a:p>
         </p:txBody>
@@ -868,7 +868,7 @@
           <a:lstStyle xmlns:a="http://schemas.openxmlformats.org/drawingml/2006/main"/>
           <a:p xmlns:a="http://schemas.openxmlformats.org/drawingml/2006/main">
             <a:r>
-              <a:t>Submission consists of public source repository, functional live demonstration no longer than 5 minutes, and this 7-slide presentation. docs/DEMO.md contains the demonstration sequence. Real trained sentiment data and own synthetic scenario data are documented separately. All shown results are reproducible; tests validate implementation, not predictive investment success. The separate organizer submission-guidelines document was not provided in full, so any additional packaging instructions must be checked there.</a:t>
+              <a:t>Domain impact is proposed decision-support usefulness, not measured efficiency. No market prediction accuracy, time saving or outperformance claim. Code https://github.com/aarohichadha/igdtuw-aarohi-chadha-hackathon . Dashboard https://aarohichadha.github.io/igdtuw-aarohi-chadha-hackathon/ . Guidelines require 10minute Unlisted YouTube recording, while original case study limits live demo5min. Recording URL and collegeemail remain candidate-dependent. Both fixeddatasets and originalpublisherCSV included. README disclosesAIassistance.</a:t>
             </a:r>
           </a:p>
         </p:txBody>
@@ -915,7 +915,7 @@
           <p:cNvPr id="3" name="Title">
             <a:extLst xmlns:a="http://schemas.openxmlformats.org/drawingml/2006/main">
               <a:ext uri="{FF2B5EF4-FFF2-40B4-BE49-F238E27FC236}">
-                <a16:creationId xmlns:a16="http://schemas.microsoft.com/office/drawing/2014/main" id="{71D915B1-25A9-446D-A31A-40F0E4C8B4CA}"/>
+                <a16:creationId xmlns:a16="http://schemas.microsoft.com/office/drawing/2014/main" id="{176048A4-5B4F-4EE8-8F4D-3447FAB98D2D}"/>
               </a:ext>
             </a:extLst>
           </p:cNvPr>
@@ -1072,7 +1072,7 @@
           <p:cNvPr id="2" name="Subtitle">
             <a:extLst xmlns:a="http://schemas.openxmlformats.org/drawingml/2006/main">
               <a:ext uri="{FF2B5EF4-FFF2-40B4-BE49-F238E27FC236}">
-                <a16:creationId xmlns:a16="http://schemas.microsoft.com/office/drawing/2014/main" id="{0CBC50DA-A00F-4B58-B995-11826FD2B843}"/>
+                <a16:creationId xmlns:a16="http://schemas.microsoft.com/office/drawing/2014/main" id="{2424C53B-7CA6-49E1-B5AB-DC12E70A8D6B}"/>
               </a:ext>
             </a:extLst>
           </p:cNvPr>
@@ -1246,7 +1246,7 @@
           <p:cNvPr id="2" name="Section title">
             <a:extLst xmlns:a="http://schemas.openxmlformats.org/drawingml/2006/main">
               <a:ext uri="{FF2B5EF4-FFF2-40B4-BE49-F238E27FC236}">
-                <a16:creationId xmlns:a16="http://schemas.microsoft.com/office/drawing/2014/main" id="{30F7499E-18D3-4330-9BBF-A9472941BAAD}"/>
+                <a16:creationId xmlns:a16="http://schemas.microsoft.com/office/drawing/2014/main" id="{99C035C0-FDCE-47DC-AD0E-B973796974D8}"/>
               </a:ext>
             </a:extLst>
           </p:cNvPr>
@@ -1420,7 +1420,7 @@
           <p:cNvPr id="3" name="Title">
             <a:extLst xmlns:a="http://schemas.openxmlformats.org/drawingml/2006/main">
               <a:ext uri="{FF2B5EF4-FFF2-40B4-BE49-F238E27FC236}">
-                <a16:creationId xmlns:a16="http://schemas.microsoft.com/office/drawing/2014/main" id="{92E4BBEF-ED45-4FE8-AC15-B577873052D5}"/>
+                <a16:creationId xmlns:a16="http://schemas.microsoft.com/office/drawing/2014/main" id="{783D105C-DC53-47EE-87B5-06D231FEF1AC}"/>
               </a:ext>
             </a:extLst>
           </p:cNvPr>
@@ -1577,7 +1577,7 @@
           <p:cNvPr id="2" name="Body">
             <a:extLst xmlns:a="http://schemas.openxmlformats.org/drawingml/2006/main">
               <a:ext uri="{FF2B5EF4-FFF2-40B4-BE49-F238E27FC236}">
-                <a16:creationId xmlns:a16="http://schemas.microsoft.com/office/drawing/2014/main" id="{0F09EF42-58EC-417A-BB2A-7A558720298E}"/>
+                <a16:creationId xmlns:a16="http://schemas.microsoft.com/office/drawing/2014/main" id="{F22887E0-8FB1-4E11-B48B-BFBAD4EAE126}"/>
               </a:ext>
             </a:extLst>
           </p:cNvPr>
@@ -1751,7 +1751,7 @@
           <p:cNvPr id="4" name="Title">
             <a:extLst xmlns:a="http://schemas.openxmlformats.org/drawingml/2006/main">
               <a:ext uri="{FF2B5EF4-FFF2-40B4-BE49-F238E27FC236}">
-                <a16:creationId xmlns:a16="http://schemas.microsoft.com/office/drawing/2014/main" id="{DCC01645-2096-436D-9974-6CE4904E5B53}"/>
+                <a16:creationId xmlns:a16="http://schemas.microsoft.com/office/drawing/2014/main" id="{5BBA63D4-FD13-4520-A7C3-8979E96AB7DA}"/>
               </a:ext>
             </a:extLst>
           </p:cNvPr>
@@ -1908,7 +1908,7 @@
           <p:cNvPr id="2" name="Left column">
             <a:extLst xmlns:a="http://schemas.openxmlformats.org/drawingml/2006/main">
               <a:ext uri="{FF2B5EF4-FFF2-40B4-BE49-F238E27FC236}">
-                <a16:creationId xmlns:a16="http://schemas.microsoft.com/office/drawing/2014/main" id="{11C1E0CC-D387-476C-936B-FC3A6EB8F8A5}"/>
+                <a16:creationId xmlns:a16="http://schemas.microsoft.com/office/drawing/2014/main" id="{DCC3F05D-A6A9-432C-9AAC-28A213E66F13}"/>
               </a:ext>
             </a:extLst>
           </p:cNvPr>
@@ -2065,7 +2065,7 @@
           <p:cNvPr id="3" name="Right column">
             <a:extLst xmlns:a="http://schemas.openxmlformats.org/drawingml/2006/main">
               <a:ext uri="{FF2B5EF4-FFF2-40B4-BE49-F238E27FC236}">
-                <a16:creationId xmlns:a16="http://schemas.microsoft.com/office/drawing/2014/main" id="{E73A2D21-FF69-4DF8-BE6F-0C905D59397A}"/>
+                <a16:creationId xmlns:a16="http://schemas.microsoft.com/office/drawing/2014/main" id="{575FE6BD-195A-447D-8584-AB9EDA385470}"/>
               </a:ext>
             </a:extLst>
           </p:cNvPr>
@@ -2239,7 +2239,7 @@
           <p:cNvPr id="3" name="Title">
             <a:extLst xmlns:a="http://schemas.openxmlformats.org/drawingml/2006/main">
               <a:ext uri="{FF2B5EF4-FFF2-40B4-BE49-F238E27FC236}">
-                <a16:creationId xmlns:a16="http://schemas.microsoft.com/office/drawing/2014/main" id="{17BA23A5-E0C7-418A-9953-35BF1C4B49C1}"/>
+                <a16:creationId xmlns:a16="http://schemas.microsoft.com/office/drawing/2014/main" id="{F68DCA12-9AD6-4BAA-BBF0-E2F17D2AEB64}"/>
               </a:ext>
             </a:extLst>
           </p:cNvPr>
@@ -2396,7 +2396,7 @@
           <p:cNvPr id="2" name="Left column">
             <a:extLst xmlns:a="http://schemas.openxmlformats.org/drawingml/2006/main">
               <a:ext uri="{FF2B5EF4-FFF2-40B4-BE49-F238E27FC236}">
-                <a16:creationId xmlns:a16="http://schemas.microsoft.com/office/drawing/2014/main" id="{F0D8D164-F93E-4605-B0EC-65C6BADDEBBC}"/>
+                <a16:creationId xmlns:a16="http://schemas.microsoft.com/office/drawing/2014/main" id="{17DC490B-3F1E-4395-A14B-1CAE3F4AB88A}"/>
               </a:ext>
             </a:extLst>
           </p:cNvPr>
@@ -2591,12 +2591,12 @@
   </p:cSld>
   <p:clrMap bg1="lt1" tx1="dk1" bg2="lt2" tx2="dk2" accent1="accent1" accent2="accent2" accent3="accent3" accent4="accent4" accent5="accent5" accent6="accent6" hlink="hlink" folHlink="folHlink"/>
   <p:sldLayoutIdLst>
-    <p:sldLayoutId xmlns:r="http://schemas.openxmlformats.org/officeDocument/2006/relationships" id="2147483649" r:id="Rdc8aab095aa04eb1"/>
-    <p:sldLayoutId xmlns:r="http://schemas.openxmlformats.org/officeDocument/2006/relationships" id="2147483650" r:id="R67e61f20fb2141eb"/>
-    <p:sldLayoutId xmlns:r="http://schemas.openxmlformats.org/officeDocument/2006/relationships" id="2147483651" r:id="Rc51a3df087534061"/>
-    <p:sldLayoutId xmlns:r="http://schemas.openxmlformats.org/officeDocument/2006/relationships" id="2147483652" r:id="R8ed1894533944004"/>
-    <p:sldLayoutId xmlns:r="http://schemas.openxmlformats.org/officeDocument/2006/relationships" id="2147483653" r:id="R4d55112605fd41eb"/>
-    <p:sldLayoutId xmlns:r="http://schemas.openxmlformats.org/officeDocument/2006/relationships" id="2147483654" r:id="R709be89fef214d97"/>
+    <p:sldLayoutId xmlns:r="http://schemas.openxmlformats.org/officeDocument/2006/relationships" id="2147483649" r:id="Ra81d8abc290c470a"/>
+    <p:sldLayoutId xmlns:r="http://schemas.openxmlformats.org/officeDocument/2006/relationships" id="2147483650" r:id="R93a7e8ec07804706"/>
+    <p:sldLayoutId xmlns:r="http://schemas.openxmlformats.org/officeDocument/2006/relationships" id="2147483651" r:id="Rdc56cd27b2374942"/>
+    <p:sldLayoutId xmlns:r="http://schemas.openxmlformats.org/officeDocument/2006/relationships" id="2147483652" r:id="Rcda882da22f34294"/>
+    <p:sldLayoutId xmlns:r="http://schemas.openxmlformats.org/officeDocument/2006/relationships" id="2147483653" r:id="R173a53d72a29499f"/>
+    <p:sldLayoutId xmlns:r="http://schemas.openxmlformats.org/officeDocument/2006/relationships" id="2147483654" r:id="R7f39e28bbe3f48e9"/>
   </p:sldLayoutIdLst>
   <p:txStyles>
     <p:titleStyle>
@@ -3555,7 +3555,7 @@
           <p:cNvPr id="4" name="">
             <a:extLst xmlns:a="http://schemas.openxmlformats.org/drawingml/2006/main">
               <a:ext uri="{FF2B5EF4-FFF2-40B4-BE49-F238E27FC236}">
-                <a16:creationId xmlns:a16="http://schemas.microsoft.com/office/drawing/2014/main" id="{869F85A6-B749-4056-BF14-BD6ECF9123FD}"/>
+                <a16:creationId xmlns:a16="http://schemas.microsoft.com/office/drawing/2014/main" id="{9856842A-17AF-44C5-B655-89220DA61B1F}"/>
               </a:ext>
             </a:extLst>
           </p:cNvPr>
@@ -3621,7 +3621,7 @@
           <p:cNvPr id="2" name="">
             <a:extLst xmlns:a="http://schemas.openxmlformats.org/drawingml/2006/main">
               <a:ext uri="{FF2B5EF4-FFF2-40B4-BE49-F238E27FC236}">
-                <a16:creationId xmlns:a16="http://schemas.microsoft.com/office/drawing/2014/main" id="{680A1DAB-F42D-44DC-8B89-47EE02C05EA8}"/>
+                <a16:creationId xmlns:a16="http://schemas.microsoft.com/office/drawing/2014/main" id="{A0372FEA-6A91-4916-964B-61798FD11D97}"/>
               </a:ext>
             </a:extLst>
           </p:cNvPr>
@@ -3633,7 +3633,7 @@
         <p:spPr>
           <a:xfrm xmlns:a="http://schemas.openxmlformats.org/drawingml/2006/main">
             <a:off x="704850" y="1666875"/>
-            <a:ext cx="10477500" cy="4095750"/>
+            <a:ext cx="10572750" cy="4095750"/>
           </a:xfrm>
           <a:prstGeom xmlns:a="http://schemas.openxmlformats.org/drawingml/2006/main" prst="rect">
             <a:avLst/>
@@ -3677,7 +3677,7 @@
                 <a:ea typeface="Arial"/>
                 <a:cs typeface="Arial"/>
               </a:rPr>
-              <a:t>Financial text → structured signals → portfolio decisions</a:t>
+              <a:t>Financial NLP and portfolio scenarios</a:t>
             </a:r>
           </a:p>
           <a:p xmlns:a="http://schemas.openxmlformats.org/drawingml/2006/main">
@@ -3705,7 +3705,7 @@
                 <a:ea typeface="Arial"/>
                 <a:cs typeface="Arial"/>
               </a:rPr>
-              <a:t>A unified AI/NLP risk engine with two applications:</a:t>
+              <a:t>Aarohi Chadha</a:t>
             </a:r>
           </a:p>
           <a:p xmlns:a="http://schemas.openxmlformats.org/drawingml/2006/main">
@@ -3728,7 +3728,12 @@
                 <a:ea typeface="Arial"/>
                 <a:cs typeface="Arial"/>
               </a:rPr>
-              <a:t>• Module A: sentiment-driven mock index rebalancing</a:t>
+              <a:t>Indira Gandhi Delhi Technical University for Women</a:t>
+            </a:r>
+          </a:p>
+          <a:p xmlns:a="http://schemas.openxmlformats.org/drawingml/2006/main">
+            <a:r>
+              <a:t/>
             </a:r>
           </a:p>
           <a:p xmlns:a="http://schemas.openxmlformats.org/drawingml/2006/main">
@@ -3751,35 +3756,7 @@
                 <a:ea typeface="Arial"/>
                 <a:cs typeface="Arial"/>
               </a:rPr>
-              <a:t>• Module B: event-triggered portfolio stress testing</a:t>
-            </a:r>
-          </a:p>
-          <a:p xmlns:a="http://schemas.openxmlformats.org/drawingml/2006/main">
-            <a:r>
-              <a:t/>
-            </a:r>
-          </a:p>
-          <a:p xmlns:a="http://schemas.openxmlformats.org/drawingml/2006/main">
-            <a:pPr>
-              <a:defRPr sz="2175" b="0">
-                <a:solidFill>
-                  <a:srgbClr val="31485B"/>
-                </a:solidFill>
-                <a:latin typeface="Arial"/>
-                <a:ea typeface="Arial"/>
-                <a:cs typeface="Arial"/>
-              </a:defRPr>
-            </a:pPr>
-            <a:r>
-              <a:rPr sz="2175" b="0">
-                <a:solidFill>
-                  <a:srgbClr val="31485B"/>
-                </a:solidFill>
-                <a:latin typeface="Arial"/>
-                <a:ea typeface="Arial"/>
-                <a:cs typeface="Arial"/>
-              </a:rPr>
-              <a:t>Aarohi Chadha  |  aarohichadha</a:t>
+              <a:t>S&amp;P Global &amp; Crisil Campus Hackathon 2026</a:t>
             </a:r>
           </a:p>
         </p:txBody>
@@ -3789,7 +3766,7 @@
           <p:cNvPr id="3" name="">
             <a:extLst xmlns:a="http://schemas.openxmlformats.org/drawingml/2006/main">
               <a:ext uri="{FF2B5EF4-FFF2-40B4-BE49-F238E27FC236}">
-                <a16:creationId xmlns:a16="http://schemas.microsoft.com/office/drawing/2014/main" id="{3EB8AD8B-6EF0-4C66-9C8E-1970603DBD90}"/>
+                <a16:creationId xmlns:a16="http://schemas.microsoft.com/office/drawing/2014/main" id="{AE042D92-7E4C-41A6-AF61-1C5209D3FFE6}"/>
               </a:ext>
             </a:extLst>
           </p:cNvPr>
@@ -3845,7 +3822,7 @@
                 <a:ea typeface="Arial"/>
                 <a:cs typeface="Arial"/>
               </a:rPr>
-              <a:t>RiskRadar • Aarohi Chadha • aarohichadha</a:t>
+              <a:t>RiskRadar   /   Aarohi Chadha   /   IGDTUW</a:t>
             </a:r>
           </a:p>
         </p:txBody>
@@ -3853,7 +3830,7 @@
     </p:spTree>
     <p:extLst>
       <p:ext uri="{BB962C8B-B14F-4D97-AF65-F5344CB8AC3E}">
-        <p14:creationId xmlns:p14="http://schemas.microsoft.com/office/powerpoint/2010/main" val="569203798"/>
+        <p14:creationId xmlns:p14="http://schemas.microsoft.com/office/powerpoint/2010/main" val="1640024417"/>
       </p:ext>
     </p:extLst>
   </p:cSld>
@@ -3884,7 +3861,7 @@
           <p:cNvPr id="4" name="">
             <a:extLst xmlns:a="http://schemas.openxmlformats.org/drawingml/2006/main">
               <a:ext uri="{FF2B5EF4-FFF2-40B4-BE49-F238E27FC236}">
-                <a16:creationId xmlns:a16="http://schemas.microsoft.com/office/drawing/2014/main" id="{B2AC617F-FE9E-48E3-8453-33F6CB8F467C}"/>
+                <a16:creationId xmlns:a16="http://schemas.microsoft.com/office/drawing/2014/main" id="{297A30B1-0E30-434C-9010-2DB98D64AFAA}"/>
               </a:ext>
             </a:extLst>
           </p:cNvPr>
@@ -3940,7 +3917,7 @@
                 <a:ea typeface="Arial"/>
                 <a:cs typeface="Arial"/>
               </a:rPr>
-              <a:t>Architecture and live data</a:t>
+              <a:t>Problem and approach</a:t>
             </a:r>
           </a:p>
         </p:txBody>
@@ -3950,7 +3927,7 @@
           <p:cNvPr id="2" name="">
             <a:extLst xmlns:a="http://schemas.openxmlformats.org/drawingml/2006/main">
               <a:ext uri="{FF2B5EF4-FFF2-40B4-BE49-F238E27FC236}">
-                <a16:creationId xmlns:a16="http://schemas.microsoft.com/office/drawing/2014/main" id="{626138BC-D3B2-4784-BDD7-C377B3DC69DA}"/>
+                <a16:creationId xmlns:a16="http://schemas.microsoft.com/office/drawing/2014/main" id="{31CC749F-5C45-4754-A3F1-8A023A2B4572}"/>
               </a:ext>
             </a:extLst>
           </p:cNvPr>
@@ -3962,7 +3939,7 @@
         <p:spPr>
           <a:xfrm xmlns:a="http://schemas.openxmlformats.org/drawingml/2006/main">
             <a:off x="704850" y="1666875"/>
-            <a:ext cx="10477500" cy="4095750"/>
+            <a:ext cx="10572750" cy="4095750"/>
           </a:xfrm>
           <a:prstGeom xmlns:a="http://schemas.openxmlformats.org/drawingml/2006/main" prst="rect">
             <a:avLst/>
@@ -4006,7 +3983,7 @@
                 <a:ea typeface="Arial"/>
                 <a:cs typeface="Arial"/>
               </a:rPr>
-              <a:t>BBC Business RSS + Guardian Business RSS</a:t>
+              <a:t>Financial news arrives as unstructured text from multiple sources</a:t>
             </a:r>
           </a:p>
           <a:p xmlns:a="http://schemas.openxmlformats.org/drawingml/2006/main">
@@ -4029,7 +4006,7 @@
                 <a:ea typeface="Arial"/>
                 <a:cs typeface="Arial"/>
               </a:rPr>
-              <a:t>Two live sources, fetched on demand or every 60 seconds</a:t>
+              <a:t>Analysts must connect an event with the exposures it could affect</a:t>
             </a:r>
           </a:p>
           <a:p xmlns:a="http://schemas.openxmlformats.org/drawingml/2006/main">
@@ -4057,7 +4034,7 @@
                 <a:ea typeface="Arial"/>
                 <a:cs typeface="Arial"/>
               </a:rPr>
-              <a:t>Shared engine: TF-IDF sentiment + event/impact rules</a:t>
+              <a:t>One engine emits sentiment, event category and severity evidence</a:t>
             </a:r>
           </a:p>
           <a:p xmlns:a="http://schemas.openxmlformats.org/drawingml/2006/main">
@@ -4080,12 +4057,7 @@
                 <a:ea typeface="Arial"/>
                 <a:cs typeface="Arial"/>
               </a:rPr>
-              <a:t>Structured JSON signals retain text, source and evidence</a:t>
-            </a:r>
-          </a:p>
-          <a:p xmlns:a="http://schemas.openxmlformats.org/drawingml/2006/main">
-            <a:r>
-              <a:t/>
+              <a:t>Two consumers demonstrate different decisions:</a:t>
             </a:r>
           </a:p>
           <a:p xmlns:a="http://schemas.openxmlformats.org/drawingml/2006/main">
@@ -4108,7 +4080,7 @@
                 <a:ea typeface="Arial"/>
                 <a:cs typeface="Arial"/>
               </a:rPr>
-              <a:t>Public dashboard + live API, with no visitor sign-in</a:t>
+              <a:t>  Module A changes sentiment weights in a mock stock index</a:t>
             </a:r>
           </a:p>
           <a:p xmlns:a="http://schemas.openxmlformats.org/drawingml/2006/main">
@@ -4131,7 +4103,7 @@
                 <a:ea typeface="Arial"/>
                 <a:cs typeface="Arial"/>
               </a:rPr>
-              <a:t>Local Python server also persists signals in SQLite</a:t>
+              <a:t>  Module B simulates asset shocks after a high-impact event</a:t>
             </a:r>
           </a:p>
         </p:txBody>
@@ -4141,7 +4113,7 @@
           <p:cNvPr id="3" name="">
             <a:extLst xmlns:a="http://schemas.openxmlformats.org/drawingml/2006/main">
               <a:ext uri="{FF2B5EF4-FFF2-40B4-BE49-F238E27FC236}">
-                <a16:creationId xmlns:a16="http://schemas.microsoft.com/office/drawing/2014/main" id="{07E4EE76-510A-4656-BE5A-72143BDB1B7C}"/>
+                <a16:creationId xmlns:a16="http://schemas.microsoft.com/office/drawing/2014/main" id="{EFF50773-1698-42B8-9E70-BDDFEE5144D5}"/>
               </a:ext>
             </a:extLst>
           </p:cNvPr>
@@ -4197,7 +4169,7 @@
                 <a:ea typeface="Arial"/>
                 <a:cs typeface="Arial"/>
               </a:rPr>
-              <a:t>RiskRadar • Aarohi Chadha • aarohichadha</a:t>
+              <a:t>RiskRadar   /   Aarohi Chadha   /   IGDTUW</a:t>
             </a:r>
           </a:p>
         </p:txBody>
@@ -4205,7 +4177,7 @@
     </p:spTree>
     <p:extLst>
       <p:ext uri="{BB962C8B-B14F-4D97-AF65-F5344CB8AC3E}">
-        <p14:creationId xmlns:p14="http://schemas.microsoft.com/office/powerpoint/2010/main" val="529103258"/>
+        <p14:creationId xmlns:p14="http://schemas.microsoft.com/office/powerpoint/2010/main" val="1975204370"/>
       </p:ext>
     </p:extLst>
   </p:cSld>
@@ -4233,10 +4205,10 @@
       </p:grpSpPr>
       <p:sp>
         <p:nvSpPr>
-          <p:cNvPr id="4" name="">
+          <p:cNvPr id="21" name="">
             <a:extLst xmlns:a="http://schemas.openxmlformats.org/drawingml/2006/main">
               <a:ext uri="{FF2B5EF4-FFF2-40B4-BE49-F238E27FC236}">
-                <a16:creationId xmlns:a16="http://schemas.microsoft.com/office/drawing/2014/main" id="{473052DF-BE1D-4425-8804-EB4223CBC6AA}"/>
+                <a16:creationId xmlns:a16="http://schemas.microsoft.com/office/drawing/2014/main" id="{2682B841-F37D-42E6-A2E3-6E707CC979FA}"/>
               </a:ext>
             </a:extLst>
           </p:cNvPr>
@@ -4292,7 +4264,7 @@
                 <a:ea typeface="Arial"/>
                 <a:cs typeface="Arial"/>
               </a:rPr>
-              <a:t>Real dataset and measured sentiment quality</a:t>
+              <a:t>System design</a:t>
             </a:r>
           </a:p>
         </p:txBody>
@@ -4302,198 +4274,7 @@
           <p:cNvPr id="2" name="">
             <a:extLst xmlns:a="http://schemas.openxmlformats.org/drawingml/2006/main">
               <a:ext uri="{FF2B5EF4-FFF2-40B4-BE49-F238E27FC236}">
-                <a16:creationId xmlns:a16="http://schemas.microsoft.com/office/drawing/2014/main" id="{79FA0949-664E-4FE9-99A2-4BE7E1C0FADD}"/>
-              </a:ext>
-            </a:extLst>
-          </p:cNvPr>
-          <p:cNvSpPr>
-            <a:spLocks xmlns:a="http://schemas.openxmlformats.org/drawingml/2006/main" noGrp="1"/>
-          </p:cNvSpPr>
-          <p:nvPr/>
-        </p:nvSpPr>
-        <p:spPr>
-          <a:xfrm xmlns:a="http://schemas.openxmlformats.org/drawingml/2006/main">
-            <a:off x="704850" y="1666875"/>
-            <a:ext cx="10477500" cy="4095750"/>
-          </a:xfrm>
-          <a:prstGeom xmlns:a="http://schemas.openxmlformats.org/drawingml/2006/main" prst="rect">
-            <a:avLst/>
-          </a:prstGeom>
-          <a:noFill xmlns:a="http://schemas.openxmlformats.org/drawingml/2006/main"/>
-          <a:ln xmlns:a="http://schemas.openxmlformats.org/drawingml/2006/main" w="0">
-            <a:noFill/>
-          </a:ln>
-        </p:spPr>
-        <p:txBody>
-          <a:bodyPr xmlns:a="http://schemas.openxmlformats.org/drawingml/2006/main"/>
-          <a:lstStyle xmlns:a="http://schemas.openxmlformats.org/drawingml/2006/main">
-            <a:defPPr>
-              <a:defRPr sz="2175" b="0">
-                <a:solidFill>
-                  <a:srgbClr val="31485B"/>
-                </a:solidFill>
-                <a:latin typeface="Arial"/>
-                <a:ea typeface="Arial"/>
-                <a:cs typeface="Arial"/>
-              </a:defRPr>
-            </a:defPPr>
-          </a:lstStyle>
-          <a:p xmlns:a="http://schemas.openxmlformats.org/drawingml/2006/main">
-            <a:pPr>
-              <a:defRPr sz="2175" b="0">
-                <a:solidFill>
-                  <a:srgbClr val="31485B"/>
-                </a:solidFill>
-                <a:latin typeface="Arial"/>
-                <a:ea typeface="Arial"/>
-                <a:cs typeface="Arial"/>
-              </a:defRPr>
-            </a:pPr>
-            <a:r>
-              <a:rPr sz="2175" b="0">
-                <a:solidFill>
-                  <a:srgbClr val="31485B"/>
-                </a:solidFill>
-                <a:latin typeface="Arial"/>
-                <a:ea typeface="Arial"/>
-                <a:cs typeface="Arial"/>
-              </a:rPr>
-              <a:t>Twitter Financial News Sentiment (publisher: zeroshot)</a:t>
-            </a:r>
-          </a:p>
-          <a:p xmlns:a="http://schemas.openxmlformats.org/drawingml/2006/main">
-            <a:pPr>
-              <a:defRPr sz="2175" b="0">
-                <a:solidFill>
-                  <a:srgbClr val="31485B"/>
-                </a:solidFill>
-                <a:latin typeface="Arial"/>
-                <a:ea typeface="Arial"/>
-                <a:cs typeface="Arial"/>
-              </a:defRPr>
-            </a:pPr>
-            <a:r>
-              <a:rPr sz="2175" b="0">
-                <a:solidFill>
-                  <a:srgbClr val="31485B"/>
-                </a:solidFill>
-                <a:latin typeface="Arial"/>
-                <a:ea typeface="Arial"/>
-                <a:cs typeface="Arial"/>
-              </a:rPr>
-              <a:t>9,374 training texts  |  2,318 evaluation texts after cleaning</a:t>
-            </a:r>
-          </a:p>
-          <a:p xmlns:a="http://schemas.openxmlformats.org/drawingml/2006/main">
-            <a:r>
-              <a:t/>
-            </a:r>
-          </a:p>
-          <a:p xmlns:a="http://schemas.openxmlformats.org/drawingml/2006/main">
-            <a:pPr>
-              <a:defRPr sz="2175" b="0">
-                <a:solidFill>
-                  <a:srgbClr val="31485B"/>
-                </a:solidFill>
-                <a:latin typeface="Arial"/>
-                <a:ea typeface="Arial"/>
-                <a:cs typeface="Arial"/>
-              </a:defRPr>
-            </a:pPr>
-            <a:r>
-              <a:rPr sz="2175" b="0">
-                <a:solidFill>
-                  <a:srgbClr val="31485B"/>
-                </a:solidFill>
-                <a:latin typeface="Arial"/>
-                <a:ea typeface="Arial"/>
-                <a:cs typeface="Arial"/>
-              </a:rPr>
-              <a:t>Held-out accuracy: 82.05%</a:t>
-            </a:r>
-          </a:p>
-          <a:p xmlns:a="http://schemas.openxmlformats.org/drawingml/2006/main">
-            <a:pPr>
-              <a:defRPr sz="2175" b="0">
-                <a:solidFill>
-                  <a:srgbClr val="31485B"/>
-                </a:solidFill>
-                <a:latin typeface="Arial"/>
-                <a:ea typeface="Arial"/>
-                <a:cs typeface="Arial"/>
-              </a:defRPr>
-            </a:pPr>
-            <a:r>
-              <a:rPr sz="2175" b="0">
-                <a:solidFill>
-                  <a:srgbClr val="31485B"/>
-                </a:solidFill>
-                <a:latin typeface="Arial"/>
-                <a:ea typeface="Arial"/>
-                <a:cs typeface="Arial"/>
-              </a:rPr>
-              <a:t>Macro F1: 0.761 across negative, neutral and positive</a:t>
-            </a:r>
-          </a:p>
-          <a:p xmlns:a="http://schemas.openxmlformats.org/drawingml/2006/main">
-            <a:r>
-              <a:t/>
-            </a:r>
-          </a:p>
-          <a:p xmlns:a="http://schemas.openxmlformats.org/drawingml/2006/main">
-            <a:pPr>
-              <a:defRPr sz="2175" b="0">
-                <a:solidFill>
-                  <a:srgbClr val="31485B"/>
-                </a:solidFill>
-                <a:latin typeface="Arial"/>
-                <a:ea typeface="Arial"/>
-                <a:cs typeface="Arial"/>
-              </a:defRPr>
-            </a:pPr>
-            <a:r>
-              <a:rPr sz="2175" b="0">
-                <a:solidFill>
-                  <a:srgbClr val="31485B"/>
-                </a:solidFill>
-                <a:latin typeface="Arial"/>
-                <a:ea typeface="Arial"/>
-                <a:cs typeface="Arial"/>
-              </a:rPr>
-              <a:t>TF-IDF unigrams/bigrams + balanced logistic regression</a:t>
-            </a:r>
-          </a:p>
-          <a:p xmlns:a="http://schemas.openxmlformats.org/drawingml/2006/main">
-            <a:pPr>
-              <a:defRPr sz="2175" b="0">
-                <a:solidFill>
-                  <a:srgbClr val="31485B"/>
-                </a:solidFill>
-                <a:latin typeface="Arial"/>
-                <a:ea typeface="Arial"/>
-                <a:cs typeface="Arial"/>
-              </a:defRPr>
-            </a:pPr>
-            <a:r>
-              <a:rPr sz="2175" b="0">
-                <a:solidFill>
-                  <a:srgbClr val="31485B"/>
-                </a:solidFill>
-                <a:latin typeface="Arial"/>
-                <a:ea typeface="Arial"/>
-                <a:cs typeface="Arial"/>
-              </a:rPr>
-              <a:t>Exact duplicates, conflicting labels and split overlap removed</a:t>
-            </a:r>
-          </a:p>
-        </p:txBody>
-      </p:sp>
-      <p:sp>
-        <p:nvSpPr>
-          <p:cNvPr id="3" name="">
-            <a:extLst xmlns:a="http://schemas.openxmlformats.org/drawingml/2006/main">
-              <a:ext uri="{FF2B5EF4-FFF2-40B4-BE49-F238E27FC236}">
-                <a16:creationId xmlns:a16="http://schemas.microsoft.com/office/drawing/2014/main" id="{390568B7-D72D-4686-AA27-3EADAECAFF58}"/>
+                <a16:creationId xmlns:a16="http://schemas.microsoft.com/office/drawing/2014/main" id="{5E916A62-0929-4F07-BB3C-86B4A0B0C8F7}"/>
               </a:ext>
             </a:extLst>
           </p:cNvPr>
@@ -4549,7 +4330,961 @@
                 <a:ea typeface="Arial"/>
                 <a:cs typeface="Arial"/>
               </a:rPr>
-              <a:t>RiskRadar • Aarohi Chadha • aarohichadha</a:t>
+              <a:t>RiskRadar   /   Aarohi Chadha   /   IGDTUW</a:t>
+            </a:r>
+          </a:p>
+        </p:txBody>
+      </p:sp>
+      <p:sp>
+        <p:nvSpPr>
+          <p:cNvPr id="3" name="">
+            <a:extLst xmlns:a="http://schemas.openxmlformats.org/drawingml/2006/main">
+              <a:ext uri="{FF2B5EF4-FFF2-40B4-BE49-F238E27FC236}">
+                <a16:creationId xmlns:a16="http://schemas.microsoft.com/office/drawing/2014/main" id="{B7A9A541-7B82-4EE4-8C01-8B74CD5143FE}"/>
+              </a:ext>
+            </a:extLst>
+          </p:cNvPr>
+          <p:cNvSpPr>
+            <a:spLocks xmlns:a="http://schemas.openxmlformats.org/drawingml/2006/main" noGrp="1"/>
+          </p:cNvSpPr>
+          <p:nvPr/>
+        </p:nvSpPr>
+        <p:spPr>
+          <a:xfrm xmlns:a="http://schemas.openxmlformats.org/drawingml/2006/main">
+            <a:off x="666750" y="1809750"/>
+            <a:ext cx="2714625" cy="1000125"/>
+          </a:xfrm>
+          <a:prstGeom xmlns:a="http://schemas.openxmlformats.org/drawingml/2006/main" prst="rect">
+            <a:avLst/>
+          </a:prstGeom>
+          <a:solidFill xmlns:a="http://schemas.openxmlformats.org/drawingml/2006/main">
+            <a:srgbClr val="FFFFFF"/>
+          </a:solidFill>
+          <a:ln xmlns:a="http://schemas.openxmlformats.org/drawingml/2006/main" w="14288">
+            <a:solidFill>
+              <a:srgbClr val="91A8B8"/>
+            </a:solidFill>
+          </a:ln>
+        </p:spPr>
+        <p:txBody>
+          <a:bodyPr xmlns:a="http://schemas.openxmlformats.org/drawingml/2006/main"/>
+          <a:lstStyle xmlns:a="http://schemas.openxmlformats.org/drawingml/2006/main">
+            <a:defPPr>
+              <a:defRPr sz="1725">
+                <a:solidFill>
+                  <a:srgbClr val="31485B"/>
+                </a:solidFill>
+                <a:latin typeface="Arial"/>
+                <a:ea typeface="Arial"/>
+                <a:cs typeface="Arial"/>
+              </a:defRPr>
+            </a:defPPr>
+          </a:lstStyle>
+          <a:p xmlns:a="http://schemas.openxmlformats.org/drawingml/2006/main">
+            <a:pPr>
+              <a:defRPr sz="1725">
+                <a:solidFill>
+                  <a:srgbClr val="31485B"/>
+                </a:solidFill>
+                <a:latin typeface="Arial"/>
+                <a:ea typeface="Arial"/>
+                <a:cs typeface="Arial"/>
+              </a:defRPr>
+            </a:pPr>
+            <a:r>
+              <a:rPr sz="1725">
+                <a:solidFill>
+                  <a:srgbClr val="31485B"/>
+                </a:solidFill>
+                <a:latin typeface="Arial"/>
+                <a:ea typeface="Arial"/>
+                <a:cs typeface="Arial"/>
+              </a:rPr>
+              <a:t>BBC + Guardian RSS</a:t>
+            </a:r>
+          </a:p>
+          <a:p xmlns:a="http://schemas.openxmlformats.org/drawingml/2006/main">
+            <a:pPr>
+              <a:defRPr sz="1725">
+                <a:solidFill>
+                  <a:srgbClr val="31485B"/>
+                </a:solidFill>
+                <a:latin typeface="Arial"/>
+                <a:ea typeface="Arial"/>
+                <a:cs typeface="Arial"/>
+              </a:defRPr>
+            </a:pPr>
+            <a:r>
+              <a:rPr sz="1725">
+                <a:solidFill>
+                  <a:srgbClr val="31485B"/>
+                </a:solidFill>
+                <a:latin typeface="Arial"/>
+                <a:ea typeface="Arial"/>
+                <a:cs typeface="Arial"/>
+              </a:rPr>
+              <a:t>Source links and timestamps</a:t>
+            </a:r>
+          </a:p>
+        </p:txBody>
+      </p:sp>
+      <p:sp>
+        <p:nvSpPr>
+          <p:cNvPr id="4" name="">
+            <a:extLst xmlns:a="http://schemas.openxmlformats.org/drawingml/2006/main">
+              <a:ext uri="{FF2B5EF4-FFF2-40B4-BE49-F238E27FC236}">
+                <a16:creationId xmlns:a16="http://schemas.microsoft.com/office/drawing/2014/main" id="{4519B257-98B1-4EC0-9FD7-9A15A6A6D265}"/>
+              </a:ext>
+            </a:extLst>
+          </p:cNvPr>
+          <p:cNvSpPr>
+            <a:spLocks xmlns:a="http://schemas.openxmlformats.org/drawingml/2006/main" noGrp="1"/>
+          </p:cNvSpPr>
+          <p:nvPr/>
+        </p:nvSpPr>
+        <p:spPr>
+          <a:xfrm xmlns:a="http://schemas.openxmlformats.org/drawingml/2006/main">
+            <a:off x="666750" y="3238500"/>
+            <a:ext cx="2714625" cy="809625"/>
+          </a:xfrm>
+          <a:prstGeom xmlns:a="http://schemas.openxmlformats.org/drawingml/2006/main" prst="rect">
+            <a:avLst/>
+          </a:prstGeom>
+          <a:solidFill xmlns:a="http://schemas.openxmlformats.org/drawingml/2006/main">
+            <a:srgbClr val="FFFFFF"/>
+          </a:solidFill>
+          <a:ln xmlns:a="http://schemas.openxmlformats.org/drawingml/2006/main" w="14288">
+            <a:solidFill>
+              <a:srgbClr val="91A8B8"/>
+            </a:solidFill>
+          </a:ln>
+        </p:spPr>
+        <p:txBody>
+          <a:bodyPr xmlns:a="http://schemas.openxmlformats.org/drawingml/2006/main"/>
+          <a:lstStyle xmlns:a="http://schemas.openxmlformats.org/drawingml/2006/main">
+            <a:defPPr>
+              <a:defRPr sz="1725">
+                <a:solidFill>
+                  <a:srgbClr val="31485B"/>
+                </a:solidFill>
+                <a:latin typeface="Arial"/>
+                <a:ea typeface="Arial"/>
+                <a:cs typeface="Arial"/>
+              </a:defRPr>
+            </a:defPPr>
+          </a:lstStyle>
+          <a:p xmlns:a="http://schemas.openxmlformats.org/drawingml/2006/main">
+            <a:pPr>
+              <a:defRPr sz="1725">
+                <a:solidFill>
+                  <a:srgbClr val="31485B"/>
+                </a:solidFill>
+                <a:latin typeface="Arial"/>
+                <a:ea typeface="Arial"/>
+                <a:cs typeface="Arial"/>
+              </a:defRPr>
+            </a:pPr>
+            <a:r>
+              <a:rPr sz="1725">
+                <a:solidFill>
+                  <a:srgbClr val="31485B"/>
+                </a:solidFill>
+                <a:latin typeface="Arial"/>
+                <a:ea typeface="Arial"/>
+                <a:cs typeface="Arial"/>
+              </a:rPr>
+              <a:t>Manual text / replay JSON</a:t>
+            </a:r>
+          </a:p>
+        </p:txBody>
+      </p:sp>
+      <p:sp>
+        <p:nvSpPr>
+          <p:cNvPr id="5" name="">
+            <a:extLst xmlns:a="http://schemas.openxmlformats.org/drawingml/2006/main">
+              <a:ext uri="{FF2B5EF4-FFF2-40B4-BE49-F238E27FC236}">
+                <a16:creationId xmlns:a16="http://schemas.microsoft.com/office/drawing/2014/main" id="{BFF597E8-2519-4A77-9C62-5BB1DDCB3B44}"/>
+              </a:ext>
+            </a:extLst>
+          </p:cNvPr>
+          <p:cNvSpPr>
+            <a:spLocks xmlns:a="http://schemas.openxmlformats.org/drawingml/2006/main" noGrp="1"/>
+          </p:cNvSpPr>
+          <p:nvPr/>
+        </p:nvSpPr>
+        <p:spPr>
+          <a:xfrm xmlns:a="http://schemas.openxmlformats.org/drawingml/2006/main">
+            <a:off x="4095750" y="2381250"/>
+            <a:ext cx="3333750" cy="1571625"/>
+          </a:xfrm>
+          <a:prstGeom xmlns:a="http://schemas.openxmlformats.org/drawingml/2006/main" prst="rect">
+            <a:avLst/>
+          </a:prstGeom>
+          <a:solidFill xmlns:a="http://schemas.openxmlformats.org/drawingml/2006/main">
+            <a:srgbClr val="FFFFFF"/>
+          </a:solidFill>
+          <a:ln xmlns:a="http://schemas.openxmlformats.org/drawingml/2006/main" w="14288">
+            <a:solidFill>
+              <a:srgbClr val="91A8B8"/>
+            </a:solidFill>
+          </a:ln>
+        </p:spPr>
+        <p:txBody>
+          <a:bodyPr xmlns:a="http://schemas.openxmlformats.org/drawingml/2006/main"/>
+          <a:lstStyle xmlns:a="http://schemas.openxmlformats.org/drawingml/2006/main">
+            <a:defPPr>
+              <a:defRPr sz="1725">
+                <a:solidFill>
+                  <a:srgbClr val="31485B"/>
+                </a:solidFill>
+                <a:latin typeface="Arial"/>
+                <a:ea typeface="Arial"/>
+                <a:cs typeface="Arial"/>
+              </a:defRPr>
+            </a:defPPr>
+          </a:lstStyle>
+          <a:p xmlns:a="http://schemas.openxmlformats.org/drawingml/2006/main">
+            <a:pPr>
+              <a:defRPr sz="1725">
+                <a:solidFill>
+                  <a:srgbClr val="31485B"/>
+                </a:solidFill>
+                <a:latin typeface="Arial"/>
+                <a:ea typeface="Arial"/>
+                <a:cs typeface="Arial"/>
+              </a:defRPr>
+            </a:pPr>
+            <a:r>
+              <a:rPr sz="1725">
+                <a:solidFill>
+                  <a:srgbClr val="31485B"/>
+                </a:solidFill>
+                <a:latin typeface="Arial"/>
+                <a:ea typeface="Arial"/>
+                <a:cs typeface="Arial"/>
+              </a:rPr>
+              <a:t>Unified NLP risk engine</a:t>
+            </a:r>
+          </a:p>
+          <a:p xmlns:a="http://schemas.openxmlformats.org/drawingml/2006/main">
+            <a:pPr>
+              <a:defRPr sz="1725">
+                <a:solidFill>
+                  <a:srgbClr val="31485B"/>
+                </a:solidFill>
+                <a:latin typeface="Arial"/>
+                <a:ea typeface="Arial"/>
+                <a:cs typeface="Arial"/>
+              </a:defRPr>
+            </a:pPr>
+            <a:r>
+              <a:rPr sz="1725">
+                <a:solidFill>
+                  <a:srgbClr val="31485B"/>
+                </a:solidFill>
+                <a:latin typeface="Arial"/>
+                <a:ea typeface="Arial"/>
+                <a:cs typeface="Arial"/>
+              </a:rPr>
+              <a:t>TF-IDF + logistic regression</a:t>
+            </a:r>
+          </a:p>
+          <a:p xmlns:a="http://schemas.openxmlformats.org/drawingml/2006/main">
+            <a:pPr>
+              <a:defRPr sz="1725">
+                <a:solidFill>
+                  <a:srgbClr val="31485B"/>
+                </a:solidFill>
+                <a:latin typeface="Arial"/>
+                <a:ea typeface="Arial"/>
+                <a:cs typeface="Arial"/>
+              </a:defRPr>
+            </a:pPr>
+            <a:r>
+              <a:rPr sz="1725">
+                <a:solidFill>
+                  <a:srgbClr val="31485B"/>
+                </a:solidFill>
+                <a:latin typeface="Arial"/>
+                <a:ea typeface="Arial"/>
+                <a:cs typeface="Arial"/>
+              </a:rPr>
+              <a:t>Event and impact rules</a:t>
+            </a:r>
+          </a:p>
+        </p:txBody>
+      </p:sp>
+      <p:sp>
+        <p:nvSpPr>
+          <p:cNvPr id="6" name="">
+            <a:extLst xmlns:a="http://schemas.openxmlformats.org/drawingml/2006/main">
+              <a:ext uri="{FF2B5EF4-FFF2-40B4-BE49-F238E27FC236}">
+                <a16:creationId xmlns:a16="http://schemas.microsoft.com/office/drawing/2014/main" id="{7F060019-7B7D-431E-871D-141B0F88B042}"/>
+              </a:ext>
+            </a:extLst>
+          </p:cNvPr>
+          <p:cNvSpPr>
+            <a:spLocks xmlns:a="http://schemas.openxmlformats.org/drawingml/2006/main" noGrp="1"/>
+          </p:cNvSpPr>
+          <p:nvPr/>
+        </p:nvSpPr>
+        <p:spPr>
+          <a:xfrm xmlns:a="http://schemas.openxmlformats.org/drawingml/2006/main">
+            <a:off x="8191500" y="1809750"/>
+            <a:ext cx="3333750" cy="1000125"/>
+          </a:xfrm>
+          <a:prstGeom xmlns:a="http://schemas.openxmlformats.org/drawingml/2006/main" prst="rect">
+            <a:avLst/>
+          </a:prstGeom>
+          <a:solidFill xmlns:a="http://schemas.openxmlformats.org/drawingml/2006/main">
+            <a:srgbClr val="FFFFFF"/>
+          </a:solidFill>
+          <a:ln xmlns:a="http://schemas.openxmlformats.org/drawingml/2006/main" w="14288">
+            <a:solidFill>
+              <a:srgbClr val="91A8B8"/>
+            </a:solidFill>
+          </a:ln>
+        </p:spPr>
+        <p:txBody>
+          <a:bodyPr xmlns:a="http://schemas.openxmlformats.org/drawingml/2006/main"/>
+          <a:lstStyle xmlns:a="http://schemas.openxmlformats.org/drawingml/2006/main">
+            <a:defPPr>
+              <a:defRPr sz="1725">
+                <a:solidFill>
+                  <a:srgbClr val="31485B"/>
+                </a:solidFill>
+                <a:latin typeface="Arial"/>
+                <a:ea typeface="Arial"/>
+                <a:cs typeface="Arial"/>
+              </a:defRPr>
+            </a:defPPr>
+          </a:lstStyle>
+          <a:p xmlns:a="http://schemas.openxmlformats.org/drawingml/2006/main">
+            <a:pPr>
+              <a:defRPr sz="1725">
+                <a:solidFill>
+                  <a:srgbClr val="31485B"/>
+                </a:solidFill>
+                <a:latin typeface="Arial"/>
+                <a:ea typeface="Arial"/>
+                <a:cs typeface="Arial"/>
+              </a:defRPr>
+            </a:pPr>
+            <a:r>
+              <a:rPr sz="1725">
+                <a:solidFill>
+                  <a:srgbClr val="31485B"/>
+                </a:solidFill>
+                <a:latin typeface="Arial"/>
+                <a:ea typeface="Arial"/>
+                <a:cs typeface="Arial"/>
+              </a:rPr>
+              <a:t>Module A</a:t>
+            </a:r>
+          </a:p>
+          <a:p xmlns:a="http://schemas.openxmlformats.org/drawingml/2006/main">
+            <a:pPr>
+              <a:defRPr sz="1725">
+                <a:solidFill>
+                  <a:srgbClr val="31485B"/>
+                </a:solidFill>
+                <a:latin typeface="Arial"/>
+                <a:ea typeface="Arial"/>
+                <a:cs typeface="Arial"/>
+              </a:defRPr>
+            </a:pPr>
+            <a:r>
+              <a:rPr sz="1725">
+                <a:solidFill>
+                  <a:srgbClr val="31485B"/>
+                </a:solidFill>
+                <a:latin typeface="Arial"/>
+                <a:ea typeface="Arial"/>
+                <a:cs typeface="Arial"/>
+              </a:rPr>
+              <a:t>Mock index weights + history</a:t>
+            </a:r>
+          </a:p>
+        </p:txBody>
+      </p:sp>
+      <p:sp>
+        <p:nvSpPr>
+          <p:cNvPr id="7" name="">
+            <a:extLst xmlns:a="http://schemas.openxmlformats.org/drawingml/2006/main">
+              <a:ext uri="{FF2B5EF4-FFF2-40B4-BE49-F238E27FC236}">
+                <a16:creationId xmlns:a16="http://schemas.microsoft.com/office/drawing/2014/main" id="{CC2F473C-AAE5-47C3-A827-7F8D6B7BE0F6}"/>
+              </a:ext>
+            </a:extLst>
+          </p:cNvPr>
+          <p:cNvSpPr>
+            <a:spLocks xmlns:a="http://schemas.openxmlformats.org/drawingml/2006/main" noGrp="1"/>
+          </p:cNvSpPr>
+          <p:nvPr/>
+        </p:nvSpPr>
+        <p:spPr>
+          <a:xfrm xmlns:a="http://schemas.openxmlformats.org/drawingml/2006/main">
+            <a:off x="8191500" y="3238500"/>
+            <a:ext cx="3333750" cy="1000125"/>
+          </a:xfrm>
+          <a:prstGeom xmlns:a="http://schemas.openxmlformats.org/drawingml/2006/main" prst="rect">
+            <a:avLst/>
+          </a:prstGeom>
+          <a:solidFill xmlns:a="http://schemas.openxmlformats.org/drawingml/2006/main">
+            <a:srgbClr val="FFFFFF"/>
+          </a:solidFill>
+          <a:ln xmlns:a="http://schemas.openxmlformats.org/drawingml/2006/main" w="14288">
+            <a:solidFill>
+              <a:srgbClr val="91A8B8"/>
+            </a:solidFill>
+          </a:ln>
+        </p:spPr>
+        <p:txBody>
+          <a:bodyPr xmlns:a="http://schemas.openxmlformats.org/drawingml/2006/main"/>
+          <a:lstStyle xmlns:a="http://schemas.openxmlformats.org/drawingml/2006/main">
+            <a:defPPr>
+              <a:defRPr sz="1725">
+                <a:solidFill>
+                  <a:srgbClr val="31485B"/>
+                </a:solidFill>
+                <a:latin typeface="Arial"/>
+                <a:ea typeface="Arial"/>
+                <a:cs typeface="Arial"/>
+              </a:defRPr>
+            </a:defPPr>
+          </a:lstStyle>
+          <a:p xmlns:a="http://schemas.openxmlformats.org/drawingml/2006/main">
+            <a:pPr>
+              <a:defRPr sz="1725">
+                <a:solidFill>
+                  <a:srgbClr val="31485B"/>
+                </a:solidFill>
+                <a:latin typeface="Arial"/>
+                <a:ea typeface="Arial"/>
+                <a:cs typeface="Arial"/>
+              </a:defRPr>
+            </a:pPr>
+            <a:r>
+              <a:rPr sz="1725">
+                <a:solidFill>
+                  <a:srgbClr val="31485B"/>
+                </a:solidFill>
+                <a:latin typeface="Arial"/>
+                <a:ea typeface="Arial"/>
+                <a:cs typeface="Arial"/>
+              </a:rPr>
+              <a:t>Module B</a:t>
+            </a:r>
+          </a:p>
+          <a:p xmlns:a="http://schemas.openxmlformats.org/drawingml/2006/main">
+            <a:pPr>
+              <a:defRPr sz="1725">
+                <a:solidFill>
+                  <a:srgbClr val="31485B"/>
+                </a:solidFill>
+                <a:latin typeface="Arial"/>
+                <a:ea typeface="Arial"/>
+                <a:cs typeface="Arial"/>
+              </a:defRPr>
+            </a:pPr>
+            <a:r>
+              <a:rPr sz="1725">
+                <a:solidFill>
+                  <a:srgbClr val="31485B"/>
+                </a:solidFill>
+                <a:latin typeface="Arial"/>
+                <a:ea typeface="Arial"/>
+                <a:cs typeface="Arial"/>
+              </a:rPr>
+              <a:t>Impact &gt; 7 triggers stress</a:t>
+            </a:r>
+          </a:p>
+        </p:txBody>
+      </p:sp>
+      <p:sp>
+        <p:nvSpPr>
+          <p:cNvPr id="8" name="">
+            <a:extLst xmlns:a="http://schemas.openxmlformats.org/drawingml/2006/main">
+              <a:ext uri="{FF2B5EF4-FFF2-40B4-BE49-F238E27FC236}">
+                <a16:creationId xmlns:a16="http://schemas.microsoft.com/office/drawing/2014/main" id="{5051428A-413E-40B8-8509-74D697B00328}"/>
+              </a:ext>
+            </a:extLst>
+          </p:cNvPr>
+          <p:cNvSpPr>
+            <a:spLocks xmlns:a="http://schemas.openxmlformats.org/drawingml/2006/main" noGrp="1"/>
+          </p:cNvSpPr>
+          <p:nvPr/>
+        </p:nvSpPr>
+        <p:spPr>
+          <a:xfrm xmlns:a="http://schemas.openxmlformats.org/drawingml/2006/main">
+            <a:off x="4095750" y="4667250"/>
+            <a:ext cx="3333750" cy="857250"/>
+          </a:xfrm>
+          <a:prstGeom xmlns:a="http://schemas.openxmlformats.org/drawingml/2006/main" prst="rect">
+            <a:avLst/>
+          </a:prstGeom>
+          <a:solidFill xmlns:a="http://schemas.openxmlformats.org/drawingml/2006/main">
+            <a:srgbClr val="FFFFFF"/>
+          </a:solidFill>
+          <a:ln xmlns:a="http://schemas.openxmlformats.org/drawingml/2006/main" w="14288">
+            <a:solidFill>
+              <a:srgbClr val="91A8B8"/>
+            </a:solidFill>
+          </a:ln>
+        </p:spPr>
+        <p:txBody>
+          <a:bodyPr xmlns:a="http://schemas.openxmlformats.org/drawingml/2006/main"/>
+          <a:lstStyle xmlns:a="http://schemas.openxmlformats.org/drawingml/2006/main">
+            <a:defPPr>
+              <a:defRPr sz="1725">
+                <a:solidFill>
+                  <a:srgbClr val="31485B"/>
+                </a:solidFill>
+                <a:latin typeface="Arial"/>
+                <a:ea typeface="Arial"/>
+                <a:cs typeface="Arial"/>
+              </a:defRPr>
+            </a:defPPr>
+          </a:lstStyle>
+          <a:p xmlns:a="http://schemas.openxmlformats.org/drawingml/2006/main">
+            <a:pPr>
+              <a:defRPr sz="1725">
+                <a:solidFill>
+                  <a:srgbClr val="31485B"/>
+                </a:solidFill>
+                <a:latin typeface="Arial"/>
+                <a:ea typeface="Arial"/>
+                <a:cs typeface="Arial"/>
+              </a:defRPr>
+            </a:pPr>
+            <a:r>
+              <a:rPr sz="1725">
+                <a:solidFill>
+                  <a:srgbClr val="31485B"/>
+                </a:solidFill>
+                <a:latin typeface="Arial"/>
+                <a:ea typeface="Arial"/>
+                <a:cs typeface="Arial"/>
+              </a:rPr>
+              <a:t>JSON API / exports</a:t>
+            </a:r>
+          </a:p>
+          <a:p xmlns:a="http://schemas.openxmlformats.org/drawingml/2006/main">
+            <a:pPr>
+              <a:defRPr sz="1725">
+                <a:solidFill>
+                  <a:srgbClr val="31485B"/>
+                </a:solidFill>
+                <a:latin typeface="Arial"/>
+                <a:ea typeface="Arial"/>
+                <a:cs typeface="Arial"/>
+              </a:defRPr>
+            </a:pPr>
+            <a:r>
+              <a:rPr sz="1725">
+                <a:solidFill>
+                  <a:srgbClr val="31485B"/>
+                </a:solidFill>
+                <a:latin typeface="Arial"/>
+                <a:ea typeface="Arial"/>
+                <a:cs typeface="Arial"/>
+              </a:rPr>
+              <a:t>Local SQLite or browser memory</a:t>
+            </a:r>
+          </a:p>
+        </p:txBody>
+      </p:sp>
+      <p:sp>
+        <p:nvSpPr>
+          <p:cNvPr id="9" name="">
+            <a:extLst xmlns:a="http://schemas.openxmlformats.org/drawingml/2006/main">
+              <a:ext uri="{FF2B5EF4-FFF2-40B4-BE49-F238E27FC236}">
+                <a16:creationId xmlns:a16="http://schemas.microsoft.com/office/drawing/2014/main" id="{C79A5091-314E-4281-8756-72770E0EAC5A}"/>
+              </a:ext>
+            </a:extLst>
+          </p:cNvPr>
+          <p:cNvSpPr>
+            <a:spLocks xmlns:a="http://schemas.openxmlformats.org/drawingml/2006/main" noGrp="1"/>
+          </p:cNvSpPr>
+          <p:nvPr/>
+        </p:nvSpPr>
+        <p:spPr>
+          <a:xfrm xmlns:a="http://schemas.openxmlformats.org/drawingml/2006/main">
+            <a:off x="3381375" y="2333625"/>
+            <a:ext cx="333375" cy="0"/>
+          </a:xfrm>
+          <a:prstGeom xmlns:a="http://schemas.openxmlformats.org/drawingml/2006/main" prst="line">
+            <a:avLst/>
+          </a:prstGeom>
+          <a:noFill xmlns:a="http://schemas.openxmlformats.org/drawingml/2006/main"/>
+          <a:ln xmlns:a="http://schemas.openxmlformats.org/drawingml/2006/main" w="28575">
+            <a:solidFill>
+              <a:srgbClr val="067B70"/>
+            </a:solidFill>
+          </a:ln>
+        </p:spPr>
+      </p:sp>
+      <p:sp>
+        <p:nvSpPr>
+          <p:cNvPr id="10" name="">
+            <a:extLst xmlns:a="http://schemas.openxmlformats.org/drawingml/2006/main">
+              <a:ext uri="{FF2B5EF4-FFF2-40B4-BE49-F238E27FC236}">
+                <a16:creationId xmlns:a16="http://schemas.microsoft.com/office/drawing/2014/main" id="{D97AC17F-8B80-4267-A3AF-BC010A6C6229}"/>
+              </a:ext>
+            </a:extLst>
+          </p:cNvPr>
+          <p:cNvSpPr>
+            <a:spLocks xmlns:a="http://schemas.openxmlformats.org/drawingml/2006/main" noGrp="1"/>
+          </p:cNvSpPr>
+          <p:nvPr/>
+        </p:nvSpPr>
+        <p:spPr>
+          <a:xfrm xmlns:a="http://schemas.openxmlformats.org/drawingml/2006/main">
+            <a:off x="3714750" y="2333625"/>
+            <a:ext cx="0" cy="428625"/>
+          </a:xfrm>
+          <a:prstGeom xmlns:a="http://schemas.openxmlformats.org/drawingml/2006/main" prst="line">
+            <a:avLst/>
+          </a:prstGeom>
+          <a:noFill xmlns:a="http://schemas.openxmlformats.org/drawingml/2006/main"/>
+          <a:ln xmlns:a="http://schemas.openxmlformats.org/drawingml/2006/main" w="28575">
+            <a:solidFill>
+              <a:srgbClr val="067B70"/>
+            </a:solidFill>
+          </a:ln>
+        </p:spPr>
+      </p:sp>
+      <p:sp>
+        <p:nvSpPr>
+          <p:cNvPr id="11" name="">
+            <a:extLst xmlns:a="http://schemas.openxmlformats.org/drawingml/2006/main">
+              <a:ext uri="{FF2B5EF4-FFF2-40B4-BE49-F238E27FC236}">
+                <a16:creationId xmlns:a16="http://schemas.microsoft.com/office/drawing/2014/main" id="{1758C7BD-B583-4A22-B76D-8B330EC5619A}"/>
+              </a:ext>
+            </a:extLst>
+          </p:cNvPr>
+          <p:cNvSpPr>
+            <a:spLocks xmlns:a="http://schemas.openxmlformats.org/drawingml/2006/main" noGrp="1"/>
+          </p:cNvSpPr>
+          <p:nvPr/>
+        </p:nvSpPr>
+        <p:spPr>
+          <a:xfrm xmlns:a="http://schemas.openxmlformats.org/drawingml/2006/main">
+            <a:off x="3714750" y="2762250"/>
+            <a:ext cx="381000" cy="0"/>
+          </a:xfrm>
+          <a:prstGeom xmlns:a="http://schemas.openxmlformats.org/drawingml/2006/main" prst="line">
+            <a:avLst/>
+          </a:prstGeom>
+          <a:noFill xmlns:a="http://schemas.openxmlformats.org/drawingml/2006/main"/>
+          <a:ln xmlns:a="http://schemas.openxmlformats.org/drawingml/2006/main" w="28575">
+            <a:solidFill>
+              <a:srgbClr val="067B70"/>
+            </a:solidFill>
+          </a:ln>
+        </p:spPr>
+      </p:sp>
+      <p:sp>
+        <p:nvSpPr>
+          <p:cNvPr id="12" name="">
+            <a:extLst xmlns:a="http://schemas.openxmlformats.org/drawingml/2006/main">
+              <a:ext uri="{FF2B5EF4-FFF2-40B4-BE49-F238E27FC236}">
+                <a16:creationId xmlns:a16="http://schemas.microsoft.com/office/drawing/2014/main" id="{BA690867-1227-4912-891E-CC54E3B03A7F}"/>
+              </a:ext>
+            </a:extLst>
+          </p:cNvPr>
+          <p:cNvSpPr>
+            <a:spLocks xmlns:a="http://schemas.openxmlformats.org/drawingml/2006/main" noGrp="1"/>
+          </p:cNvSpPr>
+          <p:nvPr/>
+        </p:nvSpPr>
+        <p:spPr>
+          <a:xfrm xmlns:a="http://schemas.openxmlformats.org/drawingml/2006/main">
+            <a:off x="3381375" y="3648075"/>
+            <a:ext cx="333375" cy="0"/>
+          </a:xfrm>
+          <a:prstGeom xmlns:a="http://schemas.openxmlformats.org/drawingml/2006/main" prst="line">
+            <a:avLst/>
+          </a:prstGeom>
+          <a:noFill xmlns:a="http://schemas.openxmlformats.org/drawingml/2006/main"/>
+          <a:ln xmlns:a="http://schemas.openxmlformats.org/drawingml/2006/main" w="28575">
+            <a:solidFill>
+              <a:srgbClr val="067B70"/>
+            </a:solidFill>
+          </a:ln>
+        </p:spPr>
+      </p:sp>
+      <p:sp>
+        <p:nvSpPr>
+          <p:cNvPr id="13" name="">
+            <a:extLst xmlns:a="http://schemas.openxmlformats.org/drawingml/2006/main">
+              <a:ext uri="{FF2B5EF4-FFF2-40B4-BE49-F238E27FC236}">
+                <a16:creationId xmlns:a16="http://schemas.microsoft.com/office/drawing/2014/main" id="{D54D6E99-100C-4CE0-9FD0-EC169751DFAB}"/>
+              </a:ext>
+            </a:extLst>
+          </p:cNvPr>
+          <p:cNvSpPr>
+            <a:spLocks xmlns:a="http://schemas.openxmlformats.org/drawingml/2006/main" noGrp="1"/>
+          </p:cNvSpPr>
+          <p:nvPr/>
+        </p:nvSpPr>
+        <p:spPr>
+          <a:xfrm xmlns:a="http://schemas.openxmlformats.org/drawingml/2006/main">
+            <a:off x="3714750" y="3362325"/>
+            <a:ext cx="0" cy="285750"/>
+          </a:xfrm>
+          <a:prstGeom xmlns:a="http://schemas.openxmlformats.org/drawingml/2006/main" prst="line">
+            <a:avLst/>
+          </a:prstGeom>
+          <a:noFill xmlns:a="http://schemas.openxmlformats.org/drawingml/2006/main"/>
+          <a:ln xmlns:a="http://schemas.openxmlformats.org/drawingml/2006/main" w="28575">
+            <a:solidFill>
+              <a:srgbClr val="067B70"/>
+            </a:solidFill>
+          </a:ln>
+        </p:spPr>
+      </p:sp>
+      <p:sp>
+        <p:nvSpPr>
+          <p:cNvPr id="14" name="">
+            <a:extLst xmlns:a="http://schemas.openxmlformats.org/drawingml/2006/main">
+              <a:ext uri="{FF2B5EF4-FFF2-40B4-BE49-F238E27FC236}">
+                <a16:creationId xmlns:a16="http://schemas.microsoft.com/office/drawing/2014/main" id="{1C79ACB4-4A94-4EB0-89CE-56134882AF61}"/>
+              </a:ext>
+            </a:extLst>
+          </p:cNvPr>
+          <p:cNvSpPr>
+            <a:spLocks xmlns:a="http://schemas.openxmlformats.org/drawingml/2006/main" noGrp="1"/>
+          </p:cNvSpPr>
+          <p:nvPr/>
+        </p:nvSpPr>
+        <p:spPr>
+          <a:xfrm xmlns:a="http://schemas.openxmlformats.org/drawingml/2006/main">
+            <a:off x="3714750" y="3362325"/>
+            <a:ext cx="381000" cy="0"/>
+          </a:xfrm>
+          <a:prstGeom xmlns:a="http://schemas.openxmlformats.org/drawingml/2006/main" prst="line">
+            <a:avLst/>
+          </a:prstGeom>
+          <a:noFill xmlns:a="http://schemas.openxmlformats.org/drawingml/2006/main"/>
+          <a:ln xmlns:a="http://schemas.openxmlformats.org/drawingml/2006/main" w="28575">
+            <a:solidFill>
+              <a:srgbClr val="067B70"/>
+            </a:solidFill>
+          </a:ln>
+        </p:spPr>
+      </p:sp>
+      <p:sp>
+        <p:nvSpPr>
+          <p:cNvPr id="15" name="">
+            <a:extLst xmlns:a="http://schemas.openxmlformats.org/drawingml/2006/main">
+              <a:ext uri="{FF2B5EF4-FFF2-40B4-BE49-F238E27FC236}">
+                <a16:creationId xmlns:a16="http://schemas.microsoft.com/office/drawing/2014/main" id="{18BAD8B4-C26F-4360-8943-9312D8F7FF47}"/>
+              </a:ext>
+            </a:extLst>
+          </p:cNvPr>
+          <p:cNvSpPr>
+            <a:spLocks xmlns:a="http://schemas.openxmlformats.org/drawingml/2006/main" noGrp="1"/>
+          </p:cNvSpPr>
+          <p:nvPr/>
+        </p:nvSpPr>
+        <p:spPr>
+          <a:xfrm xmlns:a="http://schemas.openxmlformats.org/drawingml/2006/main">
+            <a:off x="7429500" y="2762250"/>
+            <a:ext cx="381000" cy="0"/>
+          </a:xfrm>
+          <a:prstGeom xmlns:a="http://schemas.openxmlformats.org/drawingml/2006/main" prst="line">
+            <a:avLst/>
+          </a:prstGeom>
+          <a:noFill xmlns:a="http://schemas.openxmlformats.org/drawingml/2006/main"/>
+          <a:ln xmlns:a="http://schemas.openxmlformats.org/drawingml/2006/main" w="28575">
+            <a:solidFill>
+              <a:srgbClr val="067B70"/>
+            </a:solidFill>
+          </a:ln>
+        </p:spPr>
+      </p:sp>
+      <p:sp>
+        <p:nvSpPr>
+          <p:cNvPr id="16" name="">
+            <a:extLst xmlns:a="http://schemas.openxmlformats.org/drawingml/2006/main">
+              <a:ext uri="{FF2B5EF4-FFF2-40B4-BE49-F238E27FC236}">
+                <a16:creationId xmlns:a16="http://schemas.microsoft.com/office/drawing/2014/main" id="{C8697CFB-75E8-4B22-BCB0-FE217E1E65C1}"/>
+              </a:ext>
+            </a:extLst>
+          </p:cNvPr>
+          <p:cNvSpPr>
+            <a:spLocks xmlns:a="http://schemas.openxmlformats.org/drawingml/2006/main" noGrp="1"/>
+          </p:cNvSpPr>
+          <p:nvPr/>
+        </p:nvSpPr>
+        <p:spPr>
+          <a:xfrm xmlns:a="http://schemas.openxmlformats.org/drawingml/2006/main">
+            <a:off x="7810500" y="2333625"/>
+            <a:ext cx="0" cy="428625"/>
+          </a:xfrm>
+          <a:prstGeom xmlns:a="http://schemas.openxmlformats.org/drawingml/2006/main" prst="line">
+            <a:avLst/>
+          </a:prstGeom>
+          <a:noFill xmlns:a="http://schemas.openxmlformats.org/drawingml/2006/main"/>
+          <a:ln xmlns:a="http://schemas.openxmlformats.org/drawingml/2006/main" w="28575">
+            <a:solidFill>
+              <a:srgbClr val="067B70"/>
+            </a:solidFill>
+          </a:ln>
+        </p:spPr>
+      </p:sp>
+      <p:sp>
+        <p:nvSpPr>
+          <p:cNvPr id="17" name="">
+            <a:extLst xmlns:a="http://schemas.openxmlformats.org/drawingml/2006/main">
+              <a:ext uri="{FF2B5EF4-FFF2-40B4-BE49-F238E27FC236}">
+                <a16:creationId xmlns:a16="http://schemas.microsoft.com/office/drawing/2014/main" id="{99591425-9C6B-4441-8206-7F91EC907CD1}"/>
+              </a:ext>
+            </a:extLst>
+          </p:cNvPr>
+          <p:cNvSpPr>
+            <a:spLocks xmlns:a="http://schemas.openxmlformats.org/drawingml/2006/main" noGrp="1"/>
+          </p:cNvSpPr>
+          <p:nvPr/>
+        </p:nvSpPr>
+        <p:spPr>
+          <a:xfrm xmlns:a="http://schemas.openxmlformats.org/drawingml/2006/main">
+            <a:off x="7810500" y="2333625"/>
+            <a:ext cx="381000" cy="0"/>
+          </a:xfrm>
+          <a:prstGeom xmlns:a="http://schemas.openxmlformats.org/drawingml/2006/main" prst="line">
+            <a:avLst/>
+          </a:prstGeom>
+          <a:noFill xmlns:a="http://schemas.openxmlformats.org/drawingml/2006/main"/>
+          <a:ln xmlns:a="http://schemas.openxmlformats.org/drawingml/2006/main" w="28575">
+            <a:solidFill>
+              <a:srgbClr val="067B70"/>
+            </a:solidFill>
+          </a:ln>
+        </p:spPr>
+      </p:sp>
+      <p:sp>
+        <p:nvSpPr>
+          <p:cNvPr id="18" name="">
+            <a:extLst xmlns:a="http://schemas.openxmlformats.org/drawingml/2006/main">
+              <a:ext uri="{FF2B5EF4-FFF2-40B4-BE49-F238E27FC236}">
+                <a16:creationId xmlns:a16="http://schemas.microsoft.com/office/drawing/2014/main" id="{9BF52E34-757D-4CA2-9030-246845225FDB}"/>
+              </a:ext>
+            </a:extLst>
+          </p:cNvPr>
+          <p:cNvSpPr>
+            <a:spLocks xmlns:a="http://schemas.openxmlformats.org/drawingml/2006/main" noGrp="1"/>
+          </p:cNvSpPr>
+          <p:nvPr/>
+        </p:nvSpPr>
+        <p:spPr>
+          <a:xfrm xmlns:a="http://schemas.openxmlformats.org/drawingml/2006/main">
+            <a:off x="7429500" y="3571875"/>
+            <a:ext cx="762000" cy="0"/>
+          </a:xfrm>
+          <a:prstGeom xmlns:a="http://schemas.openxmlformats.org/drawingml/2006/main" prst="line">
+            <a:avLst/>
+          </a:prstGeom>
+          <a:noFill xmlns:a="http://schemas.openxmlformats.org/drawingml/2006/main"/>
+          <a:ln xmlns:a="http://schemas.openxmlformats.org/drawingml/2006/main" w="28575">
+            <a:solidFill>
+              <a:srgbClr val="067B70"/>
+            </a:solidFill>
+          </a:ln>
+        </p:spPr>
+      </p:sp>
+      <p:sp>
+        <p:nvSpPr>
+          <p:cNvPr id="19" name="">
+            <a:extLst xmlns:a="http://schemas.openxmlformats.org/drawingml/2006/main">
+              <a:ext uri="{FF2B5EF4-FFF2-40B4-BE49-F238E27FC236}">
+                <a16:creationId xmlns:a16="http://schemas.microsoft.com/office/drawing/2014/main" id="{08B2AC32-A7FC-479A-B64F-C8F148D3AAD6}"/>
+              </a:ext>
+            </a:extLst>
+          </p:cNvPr>
+          <p:cNvSpPr>
+            <a:spLocks xmlns:a="http://schemas.openxmlformats.org/drawingml/2006/main" noGrp="1"/>
+          </p:cNvSpPr>
+          <p:nvPr/>
+        </p:nvSpPr>
+        <p:spPr>
+          <a:xfrm xmlns:a="http://schemas.openxmlformats.org/drawingml/2006/main">
+            <a:off x="5762625" y="3952875"/>
+            <a:ext cx="0" cy="714375"/>
+          </a:xfrm>
+          <a:prstGeom xmlns:a="http://schemas.openxmlformats.org/drawingml/2006/main" prst="line">
+            <a:avLst/>
+          </a:prstGeom>
+          <a:noFill xmlns:a="http://schemas.openxmlformats.org/drawingml/2006/main"/>
+          <a:ln xmlns:a="http://schemas.openxmlformats.org/drawingml/2006/main" w="28575">
+            <a:solidFill>
+              <a:srgbClr val="067B70"/>
+            </a:solidFill>
+          </a:ln>
+        </p:spPr>
+      </p:sp>
+      <p:sp>
+        <p:nvSpPr>
+          <p:cNvPr id="20" name="">
+            <a:extLst xmlns:a="http://schemas.openxmlformats.org/drawingml/2006/main">
+              <a:ext uri="{FF2B5EF4-FFF2-40B4-BE49-F238E27FC236}">
+                <a16:creationId xmlns:a16="http://schemas.microsoft.com/office/drawing/2014/main" id="{3B7AA100-E089-462B-BC14-F3989D644B73}"/>
+              </a:ext>
+            </a:extLst>
+          </p:cNvPr>
+          <p:cNvSpPr>
+            <a:spLocks xmlns:a="http://schemas.openxmlformats.org/drawingml/2006/main" noGrp="1"/>
+          </p:cNvSpPr>
+          <p:nvPr/>
+        </p:nvSpPr>
+        <p:spPr>
+          <a:xfrm xmlns:a="http://schemas.openxmlformats.org/drawingml/2006/main">
+            <a:off x="704850" y="5810250"/>
+            <a:ext cx="10668000" cy="428625"/>
+          </a:xfrm>
+          <a:prstGeom xmlns:a="http://schemas.openxmlformats.org/drawingml/2006/main" prst="rect">
+            <a:avLst/>
+          </a:prstGeom>
+          <a:noFill xmlns:a="http://schemas.openxmlformats.org/drawingml/2006/main"/>
+          <a:ln xmlns:a="http://schemas.openxmlformats.org/drawingml/2006/main" w="0">
+            <a:noFill/>
+          </a:ln>
+        </p:spPr>
+        <p:txBody>
+          <a:bodyPr xmlns:a="http://schemas.openxmlformats.org/drawingml/2006/main"/>
+          <a:lstStyle xmlns:a="http://schemas.openxmlformats.org/drawingml/2006/main">
+            <a:defPPr>
+              <a:defRPr sz="1725" b="0">
+                <a:solidFill>
+                  <a:srgbClr val="64798B"/>
+                </a:solidFill>
+                <a:latin typeface="Arial"/>
+                <a:ea typeface="Arial"/>
+                <a:cs typeface="Arial"/>
+              </a:defRPr>
+            </a:defPPr>
+          </a:lstStyle>
+          <a:p xmlns:a="http://schemas.openxmlformats.org/drawingml/2006/main">
+            <a:pPr>
+              <a:defRPr sz="1725" b="0">
+                <a:solidFill>
+                  <a:srgbClr val="64798B"/>
+                </a:solidFill>
+                <a:latin typeface="Arial"/>
+                <a:ea typeface="Arial"/>
+                <a:cs typeface="Arial"/>
+              </a:defRPr>
+            </a:pPr>
+            <a:r>
+              <a:rPr sz="1725" b="0">
+                <a:solidFill>
+                  <a:srgbClr val="64798B"/>
+                </a:solidFill>
+                <a:latin typeface="Arial"/>
+                <a:ea typeface="Arial"/>
+                <a:cs typeface="Arial"/>
+              </a:rPr>
+              <a:t>Input records feed the engine, then both modules consume its structured output.</a:t>
             </a:r>
           </a:p>
         </p:txBody>
@@ -4557,7 +5292,7 @@
     </p:spTree>
     <p:extLst>
       <p:ext uri="{BB962C8B-B14F-4D97-AF65-F5344CB8AC3E}">
-        <p14:creationId xmlns:p14="http://schemas.microsoft.com/office/powerpoint/2010/main" val="1822283173"/>
+        <p14:creationId xmlns:p14="http://schemas.microsoft.com/office/powerpoint/2010/main" val="1077990311"/>
       </p:ext>
     </p:extLst>
   </p:cSld>
@@ -4588,7 +5323,7 @@
           <p:cNvPr id="4" name="">
             <a:extLst xmlns:a="http://schemas.openxmlformats.org/drawingml/2006/main">
               <a:ext uri="{FF2B5EF4-FFF2-40B4-BE49-F238E27FC236}">
-                <a16:creationId xmlns:a16="http://schemas.microsoft.com/office/drawing/2014/main" id="{ADDAFAE5-A6D7-4B76-B9E5-0177C2FD3C6B}"/>
+                <a16:creationId xmlns:a16="http://schemas.microsoft.com/office/drawing/2014/main" id="{B7CA7FF7-1644-45FE-AE31-902E07688514}"/>
               </a:ext>
             </a:extLst>
           </p:cNvPr>
@@ -4644,7 +5379,7 @@
                 <a:ea typeface="Arial"/>
                 <a:cs typeface="Arial"/>
               </a:rPr>
-              <a:t>Inspectable, machine-readable risk signals</a:t>
+              <a:t>Implementation and sentiment results</a:t>
             </a:r>
           </a:p>
         </p:txBody>
@@ -4654,7 +5389,7 @@
           <p:cNvPr id="2" name="">
             <a:extLst xmlns:a="http://schemas.openxmlformats.org/drawingml/2006/main">
               <a:ext uri="{FF2B5EF4-FFF2-40B4-BE49-F238E27FC236}">
-                <a16:creationId xmlns:a16="http://schemas.microsoft.com/office/drawing/2014/main" id="{6B9FAFB8-41C8-4933-8D7C-BA4362E12A32}"/>
+                <a16:creationId xmlns:a16="http://schemas.microsoft.com/office/drawing/2014/main" id="{FF11F36C-80F6-472F-91D7-703FB0F467C7}"/>
               </a:ext>
             </a:extLst>
           </p:cNvPr>
@@ -4666,7 +5401,7 @@
         <p:spPr>
           <a:xfrm xmlns:a="http://schemas.openxmlformats.org/drawingml/2006/main">
             <a:off x="704850" y="1666875"/>
-            <a:ext cx="10477500" cy="4095750"/>
+            <a:ext cx="10572750" cy="4095750"/>
           </a:xfrm>
           <a:prstGeom xmlns:a="http://schemas.openxmlformats.org/drawingml/2006/main" prst="rect">
             <a:avLst/>
@@ -4710,7 +5445,7 @@
                 <a:ea typeface="Arial"/>
                 <a:cs typeface="Arial"/>
               </a:rPr>
-              <a:t>Sentiment score = P(positive) − P(negative), range −1 to 1</a:t>
+              <a:t>Training: financial tweets from the public zeroshot dataset</a:t>
             </a:r>
           </a:p>
           <a:p xmlns:a="http://schemas.openxmlformats.org/drawingml/2006/main">
@@ -4733,7 +5468,12 @@
                 <a:ea typeface="Arial"/>
                 <a:cs typeface="Arial"/>
               </a:rPr>
-              <a:t>Event: geopolitical, macroeconomic, credit, M&amp;A, product or Other</a:t>
+              <a:t>9,374 training records and 2,318 evaluation records after cleaning</a:t>
+            </a:r>
+          </a:p>
+          <a:p xmlns:a="http://schemas.openxmlformats.org/drawingml/2006/main">
+            <a:r>
+              <a:t/>
             </a:r>
           </a:p>
           <a:p xmlns:a="http://schemas.openxmlformats.org/drawingml/2006/main">
@@ -4756,12 +5496,7 @@
                 <a:ea typeface="Arial"/>
                 <a:cs typeface="Arial"/>
               </a:rPr>
-              <a:t>Impact: bounded keyword severity estimate, range 1 to 10</a:t>
-            </a:r>
-          </a:p>
-          <a:p xmlns:a="http://schemas.openxmlformats.org/drawingml/2006/main">
-            <a:r>
-              <a:t/>
+              <a:t>Sentiment accuracy 82.05%     Macro F1 0.761</a:t>
             </a:r>
           </a:p>
           <a:p xmlns:a="http://schemas.openxmlformats.org/drawingml/2006/main">
@@ -4784,7 +5519,12 @@
                 <a:ea typeface="Arial"/>
                 <a:cs typeface="Arial"/>
               </a:rPr>
-              <a:t>Synthetic war replay example:</a:t>
+              <a:t>Exact duplicates, label conflicts and split overlap removed</a:t>
+            </a:r>
+          </a:p>
+          <a:p xmlns:a="http://schemas.openxmlformats.org/drawingml/2006/main">
+            <a:r>
+              <a:t/>
             </a:r>
           </a:p>
           <a:p xmlns:a="http://schemas.openxmlformats.org/drawingml/2006/main">
@@ -4807,12 +5547,7 @@
                 <a:ea typeface="Arial"/>
                 <a:cs typeface="Arial"/>
               </a:rPr>
-              <a:t>Sentiment −0.519  |  Geopolitical  |  Impact 9</a:t>
-            </a:r>
-          </a:p>
-          <a:p xmlns:a="http://schemas.openxmlformats.org/drawingml/2006/main">
-            <a:r>
-              <a:t/>
+              <a:t>Portable Python/JS inference and JSON outputs</a:t>
             </a:r>
           </a:p>
           <a:p xmlns:a="http://schemas.openxmlformats.org/drawingml/2006/main">
@@ -4835,7 +5570,7 @@
                 <a:ea typeface="Arial"/>
                 <a:cs typeface="Arial"/>
               </a:rPr>
-              <a:t>Signals include source, timestamp, probabilities and evidence</a:t>
+              <a:t>Event category and impact remain transparent keyword heuristics</a:t>
             </a:r>
           </a:p>
         </p:txBody>
@@ -4845,7 +5580,7 @@
           <p:cNvPr id="3" name="">
             <a:extLst xmlns:a="http://schemas.openxmlformats.org/drawingml/2006/main">
               <a:ext uri="{FF2B5EF4-FFF2-40B4-BE49-F238E27FC236}">
-                <a16:creationId xmlns:a16="http://schemas.microsoft.com/office/drawing/2014/main" id="{655BDE2C-AB63-4E4E-BBAC-DDEFCE87F96C}"/>
+                <a16:creationId xmlns:a16="http://schemas.microsoft.com/office/drawing/2014/main" id="{010ABAAA-ADFF-4A98-9A86-486CB9E45B15}"/>
               </a:ext>
             </a:extLst>
           </p:cNvPr>
@@ -4901,7 +5636,7 @@
                 <a:ea typeface="Arial"/>
                 <a:cs typeface="Arial"/>
               </a:rPr>
-              <a:t>RiskRadar • Aarohi Chadha • aarohichadha</a:t>
+              <a:t>RiskRadar   /   Aarohi Chadha   /   IGDTUW</a:t>
             </a:r>
           </a:p>
         </p:txBody>
@@ -4909,7 +5644,7 @@
     </p:spTree>
     <p:extLst>
       <p:ext uri="{BB962C8B-B14F-4D97-AF65-F5344CB8AC3E}">
-        <p14:creationId xmlns:p14="http://schemas.microsoft.com/office/powerpoint/2010/main" val="912121994"/>
+        <p14:creationId xmlns:p14="http://schemas.microsoft.com/office/powerpoint/2010/main" val="708506943"/>
       </p:ext>
     </p:extLst>
   </p:cSld>
@@ -4940,7 +5675,7 @@
           <p:cNvPr id="6" name="">
             <a:extLst xmlns:a="http://schemas.openxmlformats.org/drawingml/2006/main">
               <a:ext uri="{FF2B5EF4-FFF2-40B4-BE49-F238E27FC236}">
-                <a16:creationId xmlns:a16="http://schemas.microsoft.com/office/drawing/2014/main" id="{8DD03D95-DAA6-45F1-BED3-D72364095F7C}"/>
+                <a16:creationId xmlns:a16="http://schemas.microsoft.com/office/drawing/2014/main" id="{20007FF6-C47E-4317-AFE7-128D723E43BE}"/>
               </a:ext>
             </a:extLst>
           </p:cNvPr>
@@ -5006,7 +5741,7 @@
           <p:cNvPr id="2" name="">
             <a:extLst xmlns:a="http://schemas.openxmlformats.org/drawingml/2006/main">
               <a:ext uri="{FF2B5EF4-FFF2-40B4-BE49-F238E27FC236}">
-                <a16:creationId xmlns:a16="http://schemas.microsoft.com/office/drawing/2014/main" id="{0514D1D6-06A0-4A4D-8FC7-3F64D5CED784}"/>
+                <a16:creationId xmlns:a16="http://schemas.microsoft.com/office/drawing/2014/main" id="{ACB338BB-052F-4CF7-B5E4-E47B260C34CA}"/>
               </a:ext>
             </a:extLst>
           </p:cNvPr>
@@ -5136,7 +5871,7 @@
                 <a:ea typeface="Arial"/>
                 <a:cs typeface="Arial"/>
               </a:rPr>
-              <a:t>Trigger: impact score &gt; 7</a:t>
+              <a:t>War replay: impact 9 &gt; 7</a:t>
             </a:r>
           </a:p>
           <a:p xmlns:a="http://schemas.openxmlformats.org/drawingml/2006/main">
@@ -5159,7 +5894,7 @@
                 <a:ea typeface="Arial"/>
                 <a:cs typeface="Arial"/>
               </a:rPr>
-              <a:t>Each run starts from baseline</a:t>
+              <a:t>Every run starts from baseline</a:t>
             </a:r>
           </a:p>
         </p:txBody>
@@ -5169,7 +5904,7 @@
           <p:cNvPr id="3" name="">
             <a:extLst xmlns:a="http://schemas.openxmlformats.org/drawingml/2006/main">
               <a:ext uri="{FF2B5EF4-FFF2-40B4-BE49-F238E27FC236}">
-                <a16:creationId xmlns:a16="http://schemas.microsoft.com/office/drawing/2014/main" id="{662013CC-6EAE-4A4C-A4BD-3A9066C11166}"/>
+                <a16:creationId xmlns:a16="http://schemas.microsoft.com/office/drawing/2014/main" id="{D65619F9-F0F5-4A65-9668-6B87B1757AE4}"/>
               </a:ext>
             </a:extLst>
           </p:cNvPr>
@@ -5225,7 +5960,7 @@
                 <a:ea typeface="Arial"/>
                 <a:cs typeface="Arial"/>
               </a:rPr>
-              <a:t>RiskRadar • Aarohi Chadha • aarohichadha</a:t>
+              <a:t>RiskRadar   /   Aarohi Chadha   /   IGDTUW</a:t>
             </a:r>
           </a:p>
         </p:txBody>
@@ -5235,7 +5970,7 @@
           <p:cNvPr id="4" name="Chart">
             <a:extLst xmlns:a="http://schemas.openxmlformats.org/drawingml/2006/main">
               <a:ext uri="{FF2B5EF4-FFF2-40B4-BE49-F238E27FC236}">
-                <a16:creationId xmlns:a16="http://schemas.microsoft.com/office/drawing/2014/main" id="{9D10C3DE-6ADB-46F3-BD9E-FDDB491F4014}"/>
+                <a16:creationId xmlns:a16="http://schemas.microsoft.com/office/drawing/2014/main" id="{5205CBF5-358F-4423-A7B0-E523563D5DD3}"/>
               </a:ext>
             </a:extLst>
           </p:cNvPr>
@@ -5248,7 +5983,7 @@
         </p:xfrm>
         <a:graphic xmlns:a="http://schemas.openxmlformats.org/drawingml/2006/main">
           <a:graphicData uri="http://schemas.openxmlformats.org/drawingml/2006/chart">
-            <c:chart xmlns:r="http://schemas.openxmlformats.org/officeDocument/2006/relationships" xmlns:c="http://schemas.openxmlformats.org/drawingml/2006/chart" r:id="R935b01ad284a43c4"/>
+            <c:chart xmlns:r="http://schemas.openxmlformats.org/officeDocument/2006/relationships" xmlns:c="http://schemas.openxmlformats.org/drawingml/2006/chart" r:id="R2c7acde23d784b58"/>
           </a:graphicData>
         </a:graphic>
       </p:graphicFrame>
@@ -5257,7 +5992,7 @@
           <p:cNvPr id="5" name="">
             <a:extLst xmlns:a="http://schemas.openxmlformats.org/drawingml/2006/main">
               <a:ext uri="{FF2B5EF4-FFF2-40B4-BE49-F238E27FC236}">
-                <a16:creationId xmlns:a16="http://schemas.microsoft.com/office/drawing/2014/main" id="{82B7733C-DCA3-4216-BFA3-759AD15E8BF4}"/>
+                <a16:creationId xmlns:a16="http://schemas.microsoft.com/office/drawing/2014/main" id="{E182AA1F-8262-41B2-B4A0-15349A4D6FC8}"/>
               </a:ext>
             </a:extLst>
           </p:cNvPr>
@@ -5313,7 +6048,7 @@
                 <a:ea typeface="Arial"/>
                 <a:cs typeface="Arial"/>
               </a:rPr>
-              <a:t>Assumed shocks: equity −10%; rates +2 pp; credit spreads +1.5 pp.</a:t>
+              <a:t>Assumed equity shock -10%, rate shock +2 pp, credit-spread shock +1.5 pp</a:t>
             </a:r>
           </a:p>
         </p:txBody>
@@ -5321,7 +6056,7 @@
     </p:spTree>
     <p:extLst>
       <p:ext uri="{BB962C8B-B14F-4D97-AF65-F5344CB8AC3E}">
-        <p14:creationId xmlns:p14="http://schemas.microsoft.com/office/powerpoint/2010/main" val="272518805"/>
+        <p14:creationId xmlns:p14="http://schemas.microsoft.com/office/powerpoint/2010/main" val="803375498"/>
       </p:ext>
     </p:extLst>
   </p:cSld>
@@ -5352,7 +6087,7 @@
           <p:cNvPr id="5" name="">
             <a:extLst xmlns:a="http://schemas.openxmlformats.org/drawingml/2006/main">
               <a:ext uri="{FF2B5EF4-FFF2-40B4-BE49-F238E27FC236}">
-                <a16:creationId xmlns:a16="http://schemas.microsoft.com/office/drawing/2014/main" id="{5608638B-C0E2-4876-94DD-9CFF7903150C}"/>
+                <a16:creationId xmlns:a16="http://schemas.microsoft.com/office/drawing/2014/main" id="{E71FF11A-B2AC-48FB-BB89-1B62CC0CA08A}"/>
               </a:ext>
             </a:extLst>
           </p:cNvPr>
@@ -5408,7 +6143,7 @@
                 <a:ea typeface="Arial"/>
                 <a:cs typeface="Arial"/>
               </a:rPr>
-              <a:t>Module A: tactical index rebalancing</a:t>
+              <a:t>Module A: mock index rebalancing</a:t>
             </a:r>
           </a:p>
         </p:txBody>
@@ -5418,7 +6153,7 @@
           <p:cNvPr id="2" name="">
             <a:extLst xmlns:a="http://schemas.openxmlformats.org/drawingml/2006/main">
               <a:ext uri="{FF2B5EF4-FFF2-40B4-BE49-F238E27FC236}">
-                <a16:creationId xmlns:a16="http://schemas.microsoft.com/office/drawing/2014/main" id="{E5D69397-ADB5-4B68-B9AA-1AB40CE617E7}"/>
+                <a16:creationId xmlns:a16="http://schemas.microsoft.com/office/drawing/2014/main" id="{497E4E94-43DB-4397-95D6-956662FB57E3}"/>
               </a:ext>
             </a:extLst>
           </p:cNvPr>
@@ -5474,7 +6209,7 @@
                 <a:ea typeface="Arial"/>
                 <a:cs typeface="Arial"/>
               </a:rPr>
-              <a:t>Ten mock stocks start at 10% each</a:t>
+              <a:t>Ten equal starting positions, then normalized sentiment weights</a:t>
             </a:r>
           </a:p>
           <a:p xmlns:a="http://schemas.openxmlformats.org/drawingml/2006/main">
@@ -5520,7 +6255,7 @@
                 <a:ea typeface="Arial"/>
                 <a:cs typeface="Arial"/>
               </a:rPr>
-              <a:t>Normalized weights sum to 100%; history updates as signals arrive</a:t>
+              <a:t>History and JSON export make changing allocations inspectable</a:t>
             </a:r>
           </a:p>
         </p:txBody>
@@ -5530,7 +6265,7 @@
           <p:cNvPr id="3" name="">
             <a:extLst xmlns:a="http://schemas.openxmlformats.org/drawingml/2006/main">
               <a:ext uri="{FF2B5EF4-FFF2-40B4-BE49-F238E27FC236}">
-                <a16:creationId xmlns:a16="http://schemas.microsoft.com/office/drawing/2014/main" id="{5E6C2D11-6250-47E2-8938-BB639DBF7380}"/>
+                <a16:creationId xmlns:a16="http://schemas.microsoft.com/office/drawing/2014/main" id="{5E712925-9043-435F-B0C4-F3470278AA15}"/>
               </a:ext>
             </a:extLst>
           </p:cNvPr>
@@ -5586,7 +6321,7 @@
                 <a:ea typeface="Arial"/>
                 <a:cs typeface="Arial"/>
               </a:rPr>
-              <a:t>RiskRadar • Aarohi Chadha • aarohichadha</a:t>
+              <a:t>RiskRadar   /   Aarohi Chadha   /   IGDTUW</a:t>
             </a:r>
           </a:p>
         </p:txBody>
@@ -5596,7 +6331,7 @@
           <p:cNvPr id="4" name="Chart">
             <a:extLst xmlns:a="http://schemas.openxmlformats.org/drawingml/2006/main">
               <a:ext uri="{FF2B5EF4-FFF2-40B4-BE49-F238E27FC236}">
-                <a16:creationId xmlns:a16="http://schemas.microsoft.com/office/drawing/2014/main" id="{E3AA29C5-A840-4129-9EEB-06B4AD4C0F6C}"/>
+                <a16:creationId xmlns:a16="http://schemas.microsoft.com/office/drawing/2014/main" id="{D63FF14C-6109-4A83-BF0F-8382D0FB5039}"/>
               </a:ext>
             </a:extLst>
           </p:cNvPr>
@@ -5609,14 +6344,14 @@
         </p:xfrm>
         <a:graphic xmlns:a="http://schemas.openxmlformats.org/drawingml/2006/main">
           <a:graphicData uri="http://schemas.openxmlformats.org/drawingml/2006/chart">
-            <c:chart xmlns:r="http://schemas.openxmlformats.org/officeDocument/2006/relationships" xmlns:c="http://schemas.openxmlformats.org/drawingml/2006/chart" r:id="R17229f779e3741b5"/>
+            <c:chart xmlns:r="http://schemas.openxmlformats.org/officeDocument/2006/relationships" xmlns:c="http://schemas.openxmlformats.org/drawingml/2006/chart" r:id="Rc62d20e445024767"/>
           </a:graphicData>
         </a:graphic>
       </p:graphicFrame>
     </p:spTree>
     <p:extLst>
       <p:ext uri="{BB962C8B-B14F-4D97-AF65-F5344CB8AC3E}">
-        <p14:creationId xmlns:p14="http://schemas.microsoft.com/office/powerpoint/2010/main" val="1955831204"/>
+        <p14:creationId xmlns:p14="http://schemas.microsoft.com/office/powerpoint/2010/main" val="2068924412"/>
       </p:ext>
     </p:extLst>
   </p:cSld>
@@ -5647,7 +6382,7 @@
           <p:cNvPr id="4" name="">
             <a:extLst xmlns:a="http://schemas.openxmlformats.org/drawingml/2006/main">
               <a:ext uri="{FF2B5EF4-FFF2-40B4-BE49-F238E27FC236}">
-                <a16:creationId xmlns:a16="http://schemas.microsoft.com/office/drawing/2014/main" id="{95A1640A-1A07-47DB-A08A-14E474C5AC2D}"/>
+                <a16:creationId xmlns:a16="http://schemas.microsoft.com/office/drawing/2014/main" id="{A0E5D5B1-C08C-415E-AF29-9A68CC9E35C2}"/>
               </a:ext>
             </a:extLst>
           </p:cNvPr>
@@ -5703,7 +6438,7 @@
                 <a:ea typeface="Arial"/>
                 <a:cs typeface="Arial"/>
               </a:rPr>
-              <a:t>Results, limitations and submission</a:t>
+              <a:t>Domain impact, limits and next steps</a:t>
             </a:r>
           </a:p>
         </p:txBody>
@@ -5713,7 +6448,7 @@
           <p:cNvPr id="2" name="">
             <a:extLst xmlns:a="http://schemas.openxmlformats.org/drawingml/2006/main">
               <a:ext uri="{FF2B5EF4-FFF2-40B4-BE49-F238E27FC236}">
-                <a16:creationId xmlns:a16="http://schemas.microsoft.com/office/drawing/2014/main" id="{FF25A116-2E25-460A-B876-F57A68608359}"/>
+                <a16:creationId xmlns:a16="http://schemas.microsoft.com/office/drawing/2014/main" id="{133D95CC-9470-416C-A13E-1BCE1AD063F2}"/>
               </a:ext>
             </a:extLst>
           </p:cNvPr>
@@ -5725,7 +6460,7 @@
         <p:spPr>
           <a:xfrm xmlns:a="http://schemas.openxmlformats.org/drawingml/2006/main">
             <a:off x="704850" y="1666875"/>
-            <a:ext cx="10477500" cy="4095750"/>
+            <a:ext cx="10572750" cy="4095750"/>
           </a:xfrm>
           <a:prstGeom xmlns:a="http://schemas.openxmlformats.org/drawingml/2006/main" prst="rect">
             <a:avLst/>
@@ -5769,7 +6504,7 @@
                 <a:ea typeface="Arial"/>
                 <a:cs typeface="Arial"/>
               </a:rPr>
-              <a:t>Verified: 9 Python unit tests, API integration and JS parity</a:t>
+              <a:t>News triage: one inspectable format preserves source and evidence</a:t>
             </a:r>
           </a:p>
           <a:p xmlns:a="http://schemas.openxmlformats.org/drawingml/2006/main">
@@ -5792,12 +6527,7 @@
                 <a:ea typeface="Arial"/>
                 <a:cs typeface="Arial"/>
               </a:rPr>
-              <a:t>Live news ingestion, JSON exports and both downstream modules</a:t>
-            </a:r>
-          </a:p>
-          <a:p xmlns:a="http://schemas.openxmlformats.org/drawingml/2006/main">
-            <a:r>
-              <a:t/>
+              <a:t>Stress view: relate event assumptions to asset-level losses</a:t>
             </a:r>
           </a:p>
           <a:p xmlns:a="http://schemas.openxmlformats.org/drawingml/2006/main">
@@ -5820,7 +6550,12 @@
                 <a:ea typeface="Arial"/>
                 <a:cs typeface="Arial"/>
               </a:rPr>
-              <a:t>Limits: simple entity/event rules; illustrative shocks; uncalibrated scores</a:t>
+              <a:t>Mock index: demonstrate a second consumer of the same signal</a:t>
+            </a:r>
+          </a:p>
+          <a:p xmlns:a="http://schemas.openxmlformats.org/drawingml/2006/main">
+            <a:r>
+              <a:t/>
             </a:r>
           </a:p>
           <a:p xmlns:a="http://schemas.openxmlformats.org/drawingml/2006/main">
@@ -5843,12 +6578,7 @@
                 <a:ea typeface="Arial"/>
                 <a:cs typeface="Arial"/>
               </a:rPr>
-              <a:t>Next: temporal sentiment evaluation and market-calibrated scenarios</a:t>
-            </a:r>
-          </a:p>
-          <a:p xmlns:a="http://schemas.openxmlformats.org/drawingml/2006/main">
-            <a:r>
-              <a:t/>
+              <a:t>Limits: simple rules, sentiment domain shift and linear valuation</a:t>
             </a:r>
           </a:p>
           <a:p xmlns:a="http://schemas.openxmlformats.org/drawingml/2006/main">
@@ -5871,7 +6601,12 @@
                 <a:ea typeface="Arial"/>
                 <a:cs typeface="Arial"/>
               </a:rPr>
-              <a:t>Code: github.com/aarohichadha/RiskRadar</a:t>
+              <a:t>Next: temporal evaluation and market-calibrated severity/shocks</a:t>
+            </a:r>
+          </a:p>
+          <a:p xmlns:a="http://schemas.openxmlformats.org/drawingml/2006/main">
+            <a:r>
+              <a:t/>
             </a:r>
           </a:p>
           <a:p xmlns:a="http://schemas.openxmlformats.org/drawingml/2006/main">
@@ -5894,7 +6629,7 @@
                 <a:ea typeface="Arial"/>
                 <a:cs typeface="Arial"/>
               </a:rPr>
-              <a:t>Demo: aarohichadha.github.io/RiskRadar/</a:t>
+              <a:t>Public code, deck and data accompany the working dashboard</a:t>
             </a:r>
           </a:p>
         </p:txBody>
@@ -5904,7 +6639,7 @@
           <p:cNvPr id="3" name="">
             <a:extLst xmlns:a="http://schemas.openxmlformats.org/drawingml/2006/main">
               <a:ext uri="{FF2B5EF4-FFF2-40B4-BE49-F238E27FC236}">
-                <a16:creationId xmlns:a16="http://schemas.microsoft.com/office/drawing/2014/main" id="{2C1F6309-510A-4CA5-808E-D45B05574B69}"/>
+                <a16:creationId xmlns:a16="http://schemas.microsoft.com/office/drawing/2014/main" id="{803A0C27-B9EF-4382-AF3D-A5380E3693F6}"/>
               </a:ext>
             </a:extLst>
           </p:cNvPr>
@@ -5960,7 +6695,7 @@
                 <a:ea typeface="Arial"/>
                 <a:cs typeface="Arial"/>
               </a:rPr>
-              <a:t>RiskRadar • Aarohi Chadha • aarohichadha</a:t>
+              <a:t>RiskRadar   /   Aarohi Chadha   /   IGDTUW</a:t>
             </a:r>
           </a:p>
         </p:txBody>
@@ -5968,7 +6703,7 @@
     </p:spTree>
     <p:extLst>
       <p:ext uri="{BB962C8B-B14F-4D97-AF65-F5344CB8AC3E}">
-        <p14:creationId xmlns:p14="http://schemas.microsoft.com/office/powerpoint/2010/main" val="1445829220"/>
+        <p14:creationId xmlns:p14="http://schemas.microsoft.com/office/powerpoint/2010/main" val="1372840714"/>
       </p:ext>
     </p:extLst>
   </p:cSld>

</xml_diff>